<commit_message>
changes to the project
</commit_message>
<xml_diff>
--- a/teaching/CS472/Timetable/LLM-V1.pptx
+++ b/teaching/CS472/Timetable/LLM-V1.pptx
@@ -2758,7 +2758,7 @@
             </a:pPr>
             <a:r>
               <a:rPr lang="en-GB" dirty="0"/>
-              <a:t>What you’re looking at here is a real pull request. A developer asked ChatGPT for a regex to match ULIDs. ChatGPT provided something that looked correct.</a:t>
+              <a:t>What you’re looking at here is a real pull request. A reviewer asked ChatGPT for a regex to match ULIDs. ChatGPT provided something that looked correct.</a:t>
             </a:r>
           </a:p>
           <a:p>
@@ -4047,23 +4047,6 @@
           <a:bodyPr/>
           <a:lstStyle/>
           <a:p>
-            <a:pPr marL="171450" indent="-171450">
-              <a:buFontTx/>
-              <a:buChar char="-"/>
-            </a:pPr>
-            <a:r>
-              <a:rPr lang="en-GB" dirty="0"/>
-              <a:t>In our empirical study of AI-assisted pull requests, we observed four distinct integration outcomes.</a:t>
-            </a:r>
-            <a:br>
-              <a:rPr lang="en-GB" dirty="0"/>
-            </a:br>
-            <a:r>
-              <a:rPr lang="en-GB" dirty="0"/>
-              <a:t>These outcomes emerged after what we call a feedback-controlled PR evaluation process — meaning the AI suggestion goes through normal GitHub review, discussion, and refinement before a final decision is made.</a:t>
-            </a:r>
-          </a:p>
-          <a:p>
             <a:pPr marL="171450" marR="0" lvl="0" indent="-171450" algn="l" defTabSz="914400" rtl="0" eaLnBrk="1" fontAlgn="auto" latinLnBrk="0" hangingPunct="1">
               <a:lnSpc>
                 <a:spcPct val="100000"/>
@@ -4083,7 +4066,37 @@
             </a:pPr>
             <a:r>
               <a:rPr lang="en-GB" dirty="0"/>
-              <a:t>Importantly, these categories reflect integration </a:t>
+              <a:t>Importantly, these categories reflect In our empirical study of AI-assisted pull requests, we observed four distinct integration outcomes.</a:t>
+            </a:r>
+            <a:br>
+              <a:rPr lang="en-GB" dirty="0"/>
+            </a:br>
+            <a:r>
+              <a:rPr lang="en-GB" dirty="0"/>
+              <a:t>These outcomes emerged after what we call a feedback-controlled PR evaluation process — meaning the AI suggestion goes through normal GitHub review, discussion, and refinement before a final decision is made.</a:t>
+            </a:r>
+          </a:p>
+          <a:p>
+            <a:pPr marL="171450" marR="0" lvl="0" indent="-171450" algn="l" defTabSz="914400" rtl="0" eaLnBrk="1" fontAlgn="auto" latinLnBrk="0" hangingPunct="1">
+              <a:lnSpc>
+                <a:spcPct val="100000"/>
+              </a:lnSpc>
+              <a:spcBef>
+                <a:spcPts val="0"/>
+              </a:spcBef>
+              <a:spcAft>
+                <a:spcPts val="0"/>
+              </a:spcAft>
+              <a:buClrTx/>
+              <a:buSzTx/>
+              <a:buFontTx/>
+              <a:buChar char="-"/>
+              <a:tabLst/>
+              <a:defRPr/>
+            </a:pPr>
+            <a:r>
+              <a:rPr lang="en-GB" dirty="0"/>
+              <a:t>integration </a:t>
             </a:r>
             <a:r>
               <a:rPr lang="en-GB" dirty="0" err="1"/>
@@ -8462,7 +8475,7 @@
           <a:p>
             <a:r>
               <a:rPr lang="en-GB" sz="2800" b="1" dirty="0"/>
-              <a:t>PA Cases only (n=)</a:t>
+              <a:t>PA Cases only (n=116)</a:t>
             </a:r>
             <a:endParaRPr lang="en-GB" sz="2800" dirty="0"/>
           </a:p>
@@ -8661,8 +8674,8 @@
         </p:nvSpPr>
         <p:spPr>
           <a:xfrm>
-            <a:off x="6494454" y="2448707"/>
-            <a:ext cx="5455652" cy="1200329"/>
+            <a:off x="7066916" y="2144621"/>
+            <a:ext cx="4859346" cy="1200329"/>
           </a:xfrm>
           <a:prstGeom prst="rect">
             <a:avLst/>
@@ -9254,59 +9267,6 @@
       </p:grpSp>
       <p:sp>
         <p:nvSpPr>
-          <p:cNvPr id="5" name="Title 1">
-            <a:extLst>
-              <a:ext uri="{FF2B5EF4-FFF2-40B4-BE49-F238E27FC236}">
-                <a16:creationId xmlns:a16="http://schemas.microsoft.com/office/drawing/2014/main" id="{D13C2F8B-59D3-F6BB-2978-44DB9918DFB2}"/>
-              </a:ext>
-            </a:extLst>
-          </p:cNvPr>
-          <p:cNvSpPr>
-            <a:spLocks noGrp="1"/>
-          </p:cNvSpPr>
-          <p:nvPr>
-            <p:ph type="title"/>
-          </p:nvPr>
-        </p:nvSpPr>
-        <p:spPr>
-          <a:xfrm>
-            <a:off x="6925390" y="1319645"/>
-            <a:ext cx="4928500" cy="408571"/>
-          </a:xfrm>
-          <a:ln w="28575">
-            <a:solidFill>
-              <a:srgbClr val="0432FF"/>
-            </a:solidFill>
-          </a:ln>
-        </p:spPr>
-        <p:txBody>
-          <a:bodyPr>
-            <a:normAutofit fontScale="90000"/>
-          </a:bodyPr>
-          <a:lstStyle/>
-          <a:p>
-            <a:r>
-              <a:rPr lang="en-US" sz="1800" dirty="0">
-                <a:latin typeface="+mn-lt"/>
-                <a:cs typeface="Arial" panose="020B0604020202020204" pitchFamily="34" charset="0"/>
-              </a:rPr>
-              <a:t>PA Example: </a:t>
-            </a:r>
-            <a:r>
-              <a:rPr lang="en-GB" sz="1800" dirty="0">
-                <a:latin typeface="+mn-lt"/>
-              </a:rPr>
-              <a:t>Structural Integration with Adaptation</a:t>
-            </a:r>
-            <a:endParaRPr lang="en-US" sz="1800" dirty="0">
-              <a:latin typeface="+mn-lt"/>
-              <a:cs typeface="Arial" panose="020B0604020202020204" pitchFamily="34" charset="0"/>
-            </a:endParaRPr>
-          </a:p>
-        </p:txBody>
-      </p:sp>
-      <p:sp>
-        <p:nvSpPr>
           <p:cNvPr id="11" name="TextBox 10">
             <a:extLst>
               <a:ext uri="{FF2B5EF4-FFF2-40B4-BE49-F238E27FC236}">
@@ -9346,6 +9306,48 @@
               <a:t>AI suggestion was integrated, but variable names and structure were adjusted to fit project conventions.</a:t>
             </a:r>
             <a:endParaRPr lang="en-US" sz="2000" dirty="0">
+              <a:latin typeface="Arial" panose="020B0604020202020204" pitchFamily="34" charset="0"/>
+              <a:cs typeface="Arial" panose="020B0604020202020204" pitchFamily="34" charset="0"/>
+            </a:endParaRPr>
+          </a:p>
+        </p:txBody>
+      </p:sp>
+      <p:sp>
+        <p:nvSpPr>
+          <p:cNvPr id="12" name="TextBox 11">
+            <a:extLst>
+              <a:ext uri="{FF2B5EF4-FFF2-40B4-BE49-F238E27FC236}">
+                <a16:creationId xmlns:a16="http://schemas.microsoft.com/office/drawing/2014/main" id="{5251B95E-367F-3574-1DCB-9C4B50B45527}"/>
+              </a:ext>
+            </a:extLst>
+          </p:cNvPr>
+          <p:cNvSpPr txBox="1"/>
+          <p:nvPr/>
+        </p:nvSpPr>
+        <p:spPr>
+          <a:xfrm>
+            <a:off x="3021496" y="147142"/>
+            <a:ext cx="6096000" cy="523220"/>
+          </a:xfrm>
+          <a:prstGeom prst="rect">
+            <a:avLst/>
+          </a:prstGeom>
+          <a:noFill/>
+        </p:spPr>
+        <p:txBody>
+          <a:bodyPr wrap="square">
+            <a:spAutoFit/>
+          </a:bodyPr>
+          <a:lstStyle/>
+          <a:p>
+            <a:r>
+              <a:rPr lang="en-GB" sz="2800" dirty="0">
+                <a:latin typeface="Arial" panose="020B0604020202020204" pitchFamily="34" charset="0"/>
+                <a:cs typeface="Arial" panose="020B0604020202020204" pitchFamily="34" charset="0"/>
+              </a:rPr>
+              <a:t>PA Example: Code Refactoring</a:t>
+            </a:r>
+            <a:endParaRPr lang="en-US" sz="2800" dirty="0">
               <a:latin typeface="Arial" panose="020B0604020202020204" pitchFamily="34" charset="0"/>
               <a:cs typeface="Arial" panose="020B0604020202020204" pitchFamily="34" charset="0"/>
             </a:endParaRPr>
@@ -9576,51 +9578,6 @@
                                           </p:stCondLst>
                                         </p:cTn>
                                         <p:tgtEl>
-                                          <p:spTgt spid="5"/>
-                                        </p:tgtEl>
-                                        <p:attrNameLst>
-                                          <p:attrName>style.visibility</p:attrName>
-                                        </p:attrNameLst>
-                                      </p:cBhvr>
-                                      <p:to>
-                                        <p:strVal val="visible"/>
-                                      </p:to>
-                                    </p:set>
-                                  </p:childTnLst>
-                                </p:cTn>
-                              </p:par>
-                            </p:childTnLst>
-                          </p:cTn>
-                        </p:par>
-                      </p:childTnLst>
-                    </p:cTn>
-                  </p:par>
-                  <p:par>
-                    <p:cTn id="23" fill="hold">
-                      <p:stCondLst>
-                        <p:cond delay="indefinite"/>
-                      </p:stCondLst>
-                      <p:childTnLst>
-                        <p:par>
-                          <p:cTn id="24" fill="hold">
-                            <p:stCondLst>
-                              <p:cond delay="0"/>
-                            </p:stCondLst>
-                            <p:childTnLst>
-                              <p:par>
-                                <p:cTn id="25" presetID="1" presetClass="entr" presetSubtype="0" fill="hold" grpId="0" nodeType="clickEffect">
-                                  <p:stCondLst>
-                                    <p:cond delay="0"/>
-                                  </p:stCondLst>
-                                  <p:childTnLst>
-                                    <p:set>
-                                      <p:cBhvr>
-                                        <p:cTn id="26" dur="1" fill="hold">
-                                          <p:stCondLst>
-                                            <p:cond delay="0"/>
-                                          </p:stCondLst>
-                                        </p:cTn>
-                                        <p:tgtEl>
                                           <p:spTgt spid="11"/>
                                         </p:tgtEl>
                                         <p:attrNameLst>
@@ -9662,7 +9619,6 @@
       </p:par>
     </p:tnLst>
     <p:bldLst>
-      <p:bldP spid="5" grpId="0"/>
       <p:bldP spid="11" grpId="0" animBg="1"/>
     </p:bldLst>
   </p:timing>
@@ -9911,49 +9867,6 @@
           </a:extLst>
         </p:spPr>
       </p:pic>
-      <p:sp>
-        <p:nvSpPr>
-          <p:cNvPr id="5" name="TextBox 4">
-            <a:extLst>
-              <a:ext uri="{FF2B5EF4-FFF2-40B4-BE49-F238E27FC236}">
-                <a16:creationId xmlns:a16="http://schemas.microsoft.com/office/drawing/2014/main" id="{5C772CD1-74FB-9781-3BBD-9814ADB55A2D}"/>
-              </a:ext>
-            </a:extLst>
-          </p:cNvPr>
-          <p:cNvSpPr txBox="1"/>
-          <p:nvPr/>
-        </p:nvSpPr>
-        <p:spPr>
-          <a:xfrm>
-            <a:off x="4198638" y="1109948"/>
-            <a:ext cx="3751293" cy="646331"/>
-          </a:xfrm>
-          <a:prstGeom prst="rect">
-            <a:avLst/>
-          </a:prstGeom>
-          <a:noFill/>
-          <a:ln w="28575">
-            <a:solidFill>
-              <a:srgbClr val="0000EA"/>
-            </a:solidFill>
-          </a:ln>
-        </p:spPr>
-        <p:txBody>
-          <a:bodyPr wrap="square" rtlCol="0">
-            <a:spAutoFit/>
-          </a:bodyPr>
-          <a:lstStyle/>
-          <a:p>
-            <a:r>
-              <a:rPr lang="en-US" dirty="0">
-                <a:latin typeface="Arial" panose="020B0604020202020204" pitchFamily="34" charset="0"/>
-                <a:cs typeface="Arial" panose="020B0604020202020204" pitchFamily="34" charset="0"/>
-              </a:rPr>
-              <a:t>SE Task – Deployment Documentation</a:t>
-            </a:r>
-          </a:p>
-        </p:txBody>
-      </p:sp>
       <p:pic>
         <p:nvPicPr>
           <p:cNvPr id="6" name="Picture 2" descr="Chatgpt logo open ai logotype chatbot chat Vector Image">
@@ -10252,7 +10165,7 @@
                             </p:stCondLst>
                             <p:childTnLst>
                               <p:par>
-                                <p:cTn id="17" presetID="9" presetClass="entr" presetSubtype="0" fill="hold" grpId="0" nodeType="clickEffect">
+                                <p:cTn id="17" presetID="1" presetClass="entr" presetSubtype="0" fill="hold" grpId="0" nodeType="clickEffect">
                                   <p:stCondLst>
                                     <p:cond delay="0"/>
                                   </p:stCondLst>
@@ -10265,7 +10178,7 @@
                                           </p:stCondLst>
                                         </p:cTn>
                                         <p:tgtEl>
-                                          <p:spTgt spid="5"/>
+                                          <p:spTgt spid="4"/>
                                         </p:tgtEl>
                                         <p:attrNameLst>
                                           <p:attrName>style.visibility</p:attrName>
@@ -10275,14 +10188,6 @@
                                         <p:strVal val="visible"/>
                                       </p:to>
                                     </p:set>
-                                    <p:animEffect transition="in" filter="dissolve">
-                                      <p:cBhvr>
-                                        <p:cTn id="19" dur="500"/>
-                                        <p:tgtEl>
-                                          <p:spTgt spid="5"/>
-                                        </p:tgtEl>
-                                      </p:cBhvr>
-                                    </p:animEffect>
                                   </p:childTnLst>
                                 </p:cTn>
                               </p:par>
@@ -10314,8 +10219,8 @@
       </p:par>
     </p:tnLst>
     <p:bldLst>
-      <p:bldP spid="5" grpId="0" animBg="1"/>
       <p:bldP spid="9" grpId="0"/>
+      <p:bldP spid="4" grpId="0" animBg="1"/>
     </p:bldLst>
   </p:timing>
 </p:sld>
@@ -15624,7 +15529,7 @@
         <p:spPr>
           <a:xfrm>
             <a:off x="325016" y="1190155"/>
-            <a:ext cx="5066575" cy="1200329"/>
+            <a:ext cx="5066575" cy="877163"/>
           </a:xfrm>
           <a:prstGeom prst="rect">
             <a:avLst/>
@@ -15643,47 +15548,34 @@
           <a:lstStyle/>
           <a:p>
             <a:r>
-              <a:rPr lang="en-GB" b="1" dirty="0">
+              <a:rPr lang="en-GB" sz="1700" b="1" dirty="0">
                 <a:latin typeface="Arial" panose="020B0604020202020204" pitchFamily="34" charset="0"/>
                 <a:cs typeface="Arial" panose="020B0604020202020204" pitchFamily="34" charset="0"/>
               </a:rPr>
               <a:t>Conceptual guidance — no patch proposed</a:t>
             </a:r>
             <a:r>
-              <a:rPr lang="en-US" b="1" dirty="0">
+              <a:rPr lang="en-US" sz="1700" b="1" dirty="0">
                 <a:latin typeface="Arial" panose="020B0604020202020204" pitchFamily="34" charset="0"/>
                 <a:cs typeface="Arial" panose="020B0604020202020204" pitchFamily="34" charset="0"/>
               </a:rPr>
               <a:t> </a:t>
             </a:r>
             <a:r>
-              <a:rPr lang="en-US" dirty="0">
+              <a:rPr lang="en-US" sz="1700" dirty="0">
                 <a:latin typeface="Arial" panose="020B0604020202020204" pitchFamily="34" charset="0"/>
                 <a:cs typeface="Arial" panose="020B0604020202020204" pitchFamily="34" charset="0"/>
               </a:rPr>
               <a:t>- </a:t>
             </a:r>
             <a:r>
-              <a:rPr lang="en-GB" dirty="0">
+              <a:rPr lang="en-GB" sz="1700" dirty="0">
                 <a:latin typeface="Arial" panose="020B0604020202020204" pitchFamily="34" charset="0"/>
                 <a:cs typeface="Arial" panose="020B0604020202020204" pitchFamily="34" charset="0"/>
               </a:rPr>
-              <a:t>AI suggested clearer variable naming to improve readability.</a:t>
-            </a:r>
-            <a:br>
-              <a:rPr lang="en-GB" dirty="0">
-                <a:latin typeface="Arial" panose="020B0604020202020204" pitchFamily="34" charset="0"/>
-                <a:cs typeface="Arial" panose="020B0604020202020204" pitchFamily="34" charset="0"/>
-              </a:rPr>
-            </a:br>
-            <a:r>
-              <a:rPr lang="en-GB" dirty="0">
-                <a:latin typeface="Arial" panose="020B0604020202020204" pitchFamily="34" charset="0"/>
-                <a:cs typeface="Arial" panose="020B0604020202020204" pitchFamily="34" charset="0"/>
-              </a:rPr>
-              <a:t>No structural patch was evaluated.</a:t>
-            </a:r>
-            <a:endParaRPr lang="en-GB" b="0" i="0" dirty="0">
+              <a:t>AI suggested clearer variable naming to improve readability. No structural patch was evaluated.</a:t>
+            </a:r>
+            <a:endParaRPr lang="en-GB" sz="1700" b="0" i="0" dirty="0">
               <a:solidFill>
                 <a:srgbClr val="1F1F1F"/>
               </a:solidFill>
@@ -16525,7 +16417,7 @@
         </p:nvSpPr>
         <p:spPr>
           <a:xfrm>
-            <a:off x="5792061" y="5386515"/>
+            <a:off x="5792061" y="5184878"/>
             <a:ext cx="5068305" cy="830997"/>
           </a:xfrm>
           <a:prstGeom prst="rect">
@@ -16584,6 +16476,58 @@
           </a:prstGeom>
         </p:spPr>
       </p:pic>
+      <p:sp>
+        <p:nvSpPr>
+          <p:cNvPr id="12" name="Rectangle 11">
+            <a:extLst>
+              <a:ext uri="{FF2B5EF4-FFF2-40B4-BE49-F238E27FC236}">
+                <a16:creationId xmlns:a16="http://schemas.microsoft.com/office/drawing/2014/main" id="{A1CF568C-FCFC-0B9C-6A9B-00BFCFE83A00}"/>
+              </a:ext>
+            </a:extLst>
+          </p:cNvPr>
+          <p:cNvSpPr/>
+          <p:nvPr/>
+        </p:nvSpPr>
+        <p:spPr>
+          <a:xfrm>
+            <a:off x="5703214" y="2604756"/>
+            <a:ext cx="5157152" cy="630100"/>
+          </a:xfrm>
+          <a:prstGeom prst="rect">
+            <a:avLst/>
+          </a:prstGeom>
+          <a:noFill/>
+          <a:ln>
+            <a:solidFill>
+              <a:srgbClr val="C00000"/>
+            </a:solidFill>
+          </a:ln>
+        </p:spPr>
+        <p:style>
+          <a:lnRef idx="2">
+            <a:schemeClr val="accent1">
+              <a:shade val="15000"/>
+            </a:schemeClr>
+          </a:lnRef>
+          <a:fillRef idx="1">
+            <a:schemeClr val="accent1"/>
+          </a:fillRef>
+          <a:effectRef idx="0">
+            <a:schemeClr val="accent1"/>
+          </a:effectRef>
+          <a:fontRef idx="minor">
+            <a:schemeClr val="lt1"/>
+          </a:fontRef>
+        </p:style>
+        <p:txBody>
+          <a:bodyPr rtlCol="0" anchor="ctr"/>
+          <a:lstStyle/>
+          <a:p>
+            <a:pPr algn="ctr"/>
+            <a:endParaRPr lang="en-US"/>
+          </a:p>
+        </p:txBody>
+      </p:sp>
     </p:spTree>
     <p:extLst>
       <p:ext uri="{BB962C8B-B14F-4D97-AF65-F5344CB8AC3E}">
@@ -16776,6 +16720,33 @@
                                   </p:childTnLst>
                                 </p:cTn>
                               </p:par>
+                              <p:par>
+                                <p:cTn id="19" presetID="1" presetClass="entr" presetSubtype="0" fill="hold" grpId="0" nodeType="withEffect">
+                                  <p:stCondLst>
+                                    <p:cond delay="0"/>
+                                  </p:stCondLst>
+                                  <p:childTnLst>
+                                    <p:set>
+                                      <p:cBhvr>
+                                        <p:cTn id="20" dur="1" fill="hold">
+                                          <p:stCondLst>
+                                            <p:cond delay="0"/>
+                                          </p:stCondLst>
+                                        </p:cTn>
+                                        <p:tgtEl>
+                                          <p:spTgt spid="12"/>
+                                        </p:tgtEl>
+                                        <p:attrNameLst>
+                                          <p:attrName>style.visibility</p:attrName>
+                                        </p:attrNameLst>
+                                      </p:cBhvr>
+                                      <p:to>
+                                        <p:strVal val="visible"/>
+                                      </p:to>
+                                    </p:set>
+                                  </p:childTnLst>
+                                </p:cTn>
+                              </p:par>
                             </p:childTnLst>
                           </p:cTn>
                         </p:par>
@@ -16783,26 +16754,26 @@
                     </p:cTn>
                   </p:par>
                   <p:par>
-                    <p:cTn id="19" fill="hold">
+                    <p:cTn id="21" fill="hold">
                       <p:stCondLst>
                         <p:cond delay="indefinite"/>
                       </p:stCondLst>
                       <p:childTnLst>
                         <p:par>
-                          <p:cTn id="20" fill="hold">
+                          <p:cTn id="22" fill="hold">
                             <p:stCondLst>
                               <p:cond delay="0"/>
                             </p:stCondLst>
                             <p:childTnLst>
                               <p:par>
-                                <p:cTn id="21" presetID="1" presetClass="entr" presetSubtype="0" fill="hold" nodeType="clickEffect">
+                                <p:cTn id="23" presetID="1" presetClass="entr" presetSubtype="0" fill="hold" nodeType="clickEffect">
                                   <p:stCondLst>
                                     <p:cond delay="0"/>
                                   </p:stCondLst>
                                   <p:childTnLst>
                                     <p:set>
                                       <p:cBhvr>
-                                        <p:cTn id="22" dur="1" fill="hold">
+                                        <p:cTn id="24" dur="1" fill="hold">
                                           <p:stCondLst>
                                             <p:cond delay="0"/>
                                           </p:stCondLst>
@@ -16828,26 +16799,26 @@
                     </p:cTn>
                   </p:par>
                   <p:par>
-                    <p:cTn id="23" fill="hold">
+                    <p:cTn id="25" fill="hold">
                       <p:stCondLst>
                         <p:cond delay="indefinite"/>
                       </p:stCondLst>
                       <p:childTnLst>
                         <p:par>
-                          <p:cTn id="24" fill="hold">
+                          <p:cTn id="26" fill="hold">
                             <p:stCondLst>
                               <p:cond delay="0"/>
                             </p:stCondLst>
                             <p:childTnLst>
                               <p:par>
-                                <p:cTn id="25" presetID="1" presetClass="entr" presetSubtype="0" fill="hold" nodeType="clickEffect">
+                                <p:cTn id="27" presetID="1" presetClass="entr" presetSubtype="0" fill="hold" nodeType="clickEffect">
                                   <p:stCondLst>
                                     <p:cond delay="0"/>
                                   </p:stCondLst>
                                   <p:childTnLst>
                                     <p:set>
                                       <p:cBhvr>
-                                        <p:cTn id="26" dur="1" fill="hold">
+                                        <p:cTn id="28" dur="1" fill="hold">
                                           <p:stCondLst>
                                             <p:cond delay="0"/>
                                           </p:stCondLst>
@@ -16873,26 +16844,26 @@
                     </p:cTn>
                   </p:par>
                   <p:par>
-                    <p:cTn id="27" fill="hold">
+                    <p:cTn id="29" fill="hold">
                       <p:stCondLst>
                         <p:cond delay="indefinite"/>
                       </p:stCondLst>
                       <p:childTnLst>
                         <p:par>
-                          <p:cTn id="28" fill="hold">
+                          <p:cTn id="30" fill="hold">
                             <p:stCondLst>
                               <p:cond delay="0"/>
                             </p:stCondLst>
                             <p:childTnLst>
                               <p:par>
-                                <p:cTn id="29" presetID="1" presetClass="entr" presetSubtype="0" fill="hold" grpId="0" nodeType="clickEffect">
+                                <p:cTn id="31" presetID="1" presetClass="entr" presetSubtype="0" fill="hold" grpId="0" nodeType="clickEffect">
                                   <p:stCondLst>
                                     <p:cond delay="0"/>
                                   </p:stCondLst>
                                   <p:childTnLst>
                                     <p:set>
                                       <p:cBhvr>
-                                        <p:cTn id="30" dur="1" fill="hold">
+                                        <p:cTn id="32" dur="1" fill="hold">
                                           <p:stCondLst>
                                             <p:cond delay="0"/>
                                           </p:stCondLst>
@@ -16918,26 +16889,26 @@
                     </p:cTn>
                   </p:par>
                   <p:par>
-                    <p:cTn id="31" fill="hold">
+                    <p:cTn id="33" fill="hold">
                       <p:stCondLst>
                         <p:cond delay="indefinite"/>
                       </p:stCondLst>
                       <p:childTnLst>
                         <p:par>
-                          <p:cTn id="32" fill="hold">
+                          <p:cTn id="34" fill="hold">
                             <p:stCondLst>
                               <p:cond delay="0"/>
                             </p:stCondLst>
                             <p:childTnLst>
                               <p:par>
-                                <p:cTn id="33" presetID="1" presetClass="entr" presetSubtype="0" fill="hold" grpId="0" nodeType="clickEffect">
+                                <p:cTn id="35" presetID="1" presetClass="entr" presetSubtype="0" fill="hold" grpId="0" nodeType="clickEffect">
                                   <p:stCondLst>
                                     <p:cond delay="0"/>
                                   </p:stCondLst>
                                   <p:childTnLst>
                                     <p:set>
                                       <p:cBhvr>
-                                        <p:cTn id="34" dur="1" fill="hold">
+                                        <p:cTn id="36" dur="1" fill="hold">
                                           <p:stCondLst>
                                             <p:cond delay="0"/>
                                           </p:stCondLst>
@@ -16986,6 +16957,7 @@
     <p:bldLst>
       <p:bldP spid="5" grpId="0" animBg="1"/>
       <p:bldP spid="39" grpId="0" animBg="1"/>
+      <p:bldP spid="12" grpId="0" animBg="1"/>
     </p:bldLst>
   </p:timing>
 </p:sld>
@@ -17624,8 +17596,8 @@
         </p:nvSpPr>
         <p:spPr>
           <a:xfrm>
-            <a:off x="1375646" y="2585431"/>
-            <a:ext cx="3727397" cy="276999"/>
+            <a:off x="948563" y="2653318"/>
+            <a:ext cx="3697865" cy="261610"/>
           </a:xfrm>
           <a:prstGeom prst="rect">
             <a:avLst/>
@@ -17644,10 +17616,10 @@
           <a:lstStyle/>
           <a:p>
             <a:r>
-              <a:rPr lang="en-GB" sz="1200" dirty="0"/>
+              <a:rPr lang="en-GB" sz="1100" dirty="0"/>
               <a:t>Installation of different architectures (arm64 vs. x86_64)</a:t>
             </a:r>
-            <a:endParaRPr lang="en-US" sz="1200" dirty="0"/>
+            <a:endParaRPr lang="en-US" sz="1100" dirty="0"/>
           </a:p>
         </p:txBody>
       </p:sp>
@@ -18080,10 +18052,94 @@
           <a:bodyPr/>
           <a:lstStyle/>
           <a:p>
+            <a:r>
+              <a:rPr lang="en-US" dirty="0"/>
+              <a:t>Grades for Lab 1 and 2 by the end of this week</a:t>
+            </a:r>
+          </a:p>
+          <a:p>
+            <a:r>
+              <a:rPr lang="en-US" dirty="0"/>
+              <a:t>Start working on DP II</a:t>
+            </a:r>
+          </a:p>
+          <a:p>
             <a:endParaRPr lang="en-US" dirty="0"/>
           </a:p>
         </p:txBody>
       </p:sp>
+      <p:pic>
+        <p:nvPicPr>
+          <p:cNvPr id="5" name="Picture 4" descr="A white text with black text&#10;&#10;AI-generated content may be incorrect.">
+            <a:extLst>
+              <a:ext uri="{FF2B5EF4-FFF2-40B4-BE49-F238E27FC236}">
+                <a16:creationId xmlns:a16="http://schemas.microsoft.com/office/drawing/2014/main" id="{64DADCC6-791F-5C94-C6CB-32A6A1DC62BA}"/>
+              </a:ext>
+            </a:extLst>
+          </p:cNvPr>
+          <p:cNvPicPr>
+            <a:picLocks noChangeAspect="1"/>
+          </p:cNvPicPr>
+          <p:nvPr/>
+        </p:nvPicPr>
+        <p:blipFill>
+          <a:blip r:embed="rId2"/>
+          <a:stretch>
+            <a:fillRect/>
+          </a:stretch>
+        </p:blipFill>
+        <p:spPr>
+          <a:xfrm>
+            <a:off x="704849" y="3302794"/>
+            <a:ext cx="7780123" cy="3009106"/>
+          </a:xfrm>
+          <a:prstGeom prst="rect">
+            <a:avLst/>
+          </a:prstGeom>
+        </p:spPr>
+      </p:pic>
+      <p:cxnSp>
+        <p:nvCxnSpPr>
+          <p:cNvPr id="7" name="Straight Arrow Connector 6">
+            <a:extLst>
+              <a:ext uri="{FF2B5EF4-FFF2-40B4-BE49-F238E27FC236}">
+                <a16:creationId xmlns:a16="http://schemas.microsoft.com/office/drawing/2014/main" id="{C7F517E2-CAEB-5385-0B5F-EBD20D32D554}"/>
+              </a:ext>
+            </a:extLst>
+          </p:cNvPr>
+          <p:cNvCxnSpPr/>
+          <p:nvPr/>
+        </p:nvCxnSpPr>
+        <p:spPr>
+          <a:xfrm flipH="1">
+            <a:off x="4594910" y="5198533"/>
+            <a:ext cx="4650690" cy="694267"/>
+          </a:xfrm>
+          <a:prstGeom prst="straightConnector1">
+            <a:avLst/>
+          </a:prstGeom>
+          <a:ln w="38100">
+            <a:solidFill>
+              <a:srgbClr val="C00000"/>
+            </a:solidFill>
+            <a:tailEnd type="triangle"/>
+          </a:ln>
+        </p:spPr>
+        <p:style>
+          <a:lnRef idx="2">
+            <a:schemeClr val="accent1"/>
+          </a:lnRef>
+          <a:fillRef idx="0">
+            <a:schemeClr val="accent1"/>
+          </a:fillRef>
+          <a:effectRef idx="1">
+            <a:schemeClr val="accent1"/>
+          </a:effectRef>
+          <a:fontRef idx="minor">
+            <a:schemeClr val="tx1"/>
+          </a:fontRef>
+        </p:style>
+      </p:cxnSp>
     </p:spTree>
     <p:extLst>
       <p:ext uri="{BB962C8B-B14F-4D97-AF65-F5344CB8AC3E}">
@@ -18094,6 +18150,108 @@
   <p:clrMapOvr>
     <a:masterClrMapping/>
   </p:clrMapOvr>
+  <p:timing>
+    <p:tnLst>
+      <p:par>
+        <p:cTn id="1" dur="indefinite" restart="never" nodeType="tmRoot">
+          <p:childTnLst>
+            <p:seq concurrent="1" nextAc="seek">
+              <p:cTn id="2" dur="indefinite" nodeType="mainSeq">
+                <p:childTnLst>
+                  <p:par>
+                    <p:cTn id="3" fill="hold">
+                      <p:stCondLst>
+                        <p:cond delay="indefinite"/>
+                      </p:stCondLst>
+                      <p:childTnLst>
+                        <p:par>
+                          <p:cTn id="4" fill="hold">
+                            <p:stCondLst>
+                              <p:cond delay="0"/>
+                            </p:stCondLst>
+                            <p:childTnLst>
+                              <p:par>
+                                <p:cTn id="5" presetID="1" presetClass="entr" presetSubtype="0" fill="hold" nodeType="clickEffect">
+                                  <p:stCondLst>
+                                    <p:cond delay="0"/>
+                                  </p:stCondLst>
+                                  <p:childTnLst>
+                                    <p:set>
+                                      <p:cBhvr>
+                                        <p:cTn id="6" dur="1" fill="hold">
+                                          <p:stCondLst>
+                                            <p:cond delay="0"/>
+                                          </p:stCondLst>
+                                        </p:cTn>
+                                        <p:tgtEl>
+                                          <p:spTgt spid="5"/>
+                                        </p:tgtEl>
+                                        <p:attrNameLst>
+                                          <p:attrName>style.visibility</p:attrName>
+                                        </p:attrNameLst>
+                                      </p:cBhvr>
+                                      <p:to>
+                                        <p:strVal val="visible"/>
+                                      </p:to>
+                                    </p:set>
+                                  </p:childTnLst>
+                                </p:cTn>
+                              </p:par>
+                              <p:par>
+                                <p:cTn id="7" presetID="1" presetClass="entr" presetSubtype="0" fill="hold" nodeType="withEffect">
+                                  <p:stCondLst>
+                                    <p:cond delay="0"/>
+                                  </p:stCondLst>
+                                  <p:childTnLst>
+                                    <p:set>
+                                      <p:cBhvr>
+                                        <p:cTn id="8" dur="1" fill="hold">
+                                          <p:stCondLst>
+                                            <p:cond delay="0"/>
+                                          </p:stCondLst>
+                                        </p:cTn>
+                                        <p:tgtEl>
+                                          <p:spTgt spid="7"/>
+                                        </p:tgtEl>
+                                        <p:attrNameLst>
+                                          <p:attrName>style.visibility</p:attrName>
+                                        </p:attrNameLst>
+                                      </p:cBhvr>
+                                      <p:to>
+                                        <p:strVal val="visible"/>
+                                      </p:to>
+                                    </p:set>
+                                  </p:childTnLst>
+                                </p:cTn>
+                              </p:par>
+                            </p:childTnLst>
+                          </p:cTn>
+                        </p:par>
+                      </p:childTnLst>
+                    </p:cTn>
+                  </p:par>
+                </p:childTnLst>
+              </p:cTn>
+              <p:prevCondLst>
+                <p:cond evt="onPrev" delay="0">
+                  <p:tgtEl>
+                    <p:sldTgt/>
+                  </p:tgtEl>
+                </p:cond>
+              </p:prevCondLst>
+              <p:nextCondLst>
+                <p:cond evt="onNext" delay="0">
+                  <p:tgtEl>
+                    <p:sldTgt/>
+                  </p:tgtEl>
+                </p:cond>
+              </p:nextCondLst>
+            </p:seq>
+          </p:childTnLst>
+        </p:cTn>
+      </p:par>
+    </p:tnLst>
+  </p:timing>
 </p:sld>
 </file>
 
@@ -22434,17 +22592,19 @@
           </a:bodyPr>
           <a:lstStyle/>
           <a:p>
-            <a:pPr algn="ctr"/>
             <a:r>
               <a:rPr lang="en-GB" sz="2400" dirty="0"/>
               <a:t>The issue is not whether to use GenAI — it is how to use it professionally.</a:t>
             </a:r>
           </a:p>
           <a:p>
-            <a:pPr algn="ctr"/>
+            <a:pPr marL="342900" indent="-342900">
+              <a:buFont typeface="Arial" panose="020B0604020202020204" pitchFamily="34" charset="0"/>
+              <a:buChar char="•"/>
+            </a:pPr>
             <a:r>
               <a:rPr lang="en-GB" sz="2400" dirty="0"/>
-              <a:t>- What does professional GenAI usage look like inside a pull request?</a:t>
+              <a:t>What does professional GenAI usage look like inside a pull request?</a:t>
             </a:r>
             <a:endParaRPr lang="en-US" sz="2400" dirty="0"/>
           </a:p>
@@ -22742,7 +22902,7 @@
         </p:nvGrpSpPr>
         <p:grpSpPr>
           <a:xfrm>
-            <a:off x="819404" y="3963245"/>
+            <a:off x="827746" y="3624511"/>
             <a:ext cx="4366096" cy="1724862"/>
             <a:chOff x="381000" y="1648765"/>
             <a:chExt cx="4495800" cy="1549400"/>
@@ -22828,10 +22988,10 @@
       </p:grpSp>
       <p:grpSp>
         <p:nvGrpSpPr>
-          <p:cNvPr id="21" name="Group 20">
+          <p:cNvPr id="24" name="Group 23">
             <a:extLst>
               <a:ext uri="{FF2B5EF4-FFF2-40B4-BE49-F238E27FC236}">
-                <a16:creationId xmlns:a16="http://schemas.microsoft.com/office/drawing/2014/main" id="{68E65E08-4D21-FDCB-DDFD-F068210BEB2E}"/>
+                <a16:creationId xmlns:a16="http://schemas.microsoft.com/office/drawing/2014/main" id="{41F6846A-C4D0-7241-F688-E72994E5FF44}"/>
               </a:ext>
             </a:extLst>
           </p:cNvPr>
@@ -22840,251 +23000,91 @@
         </p:nvGrpSpPr>
         <p:grpSpPr>
           <a:xfrm>
-            <a:off x="6127376" y="1124257"/>
-            <a:ext cx="5810559" cy="5639614"/>
-            <a:chOff x="5190816" y="1219780"/>
-            <a:chExt cx="5810559" cy="5639614"/>
+            <a:off x="6316343" y="1124257"/>
+            <a:ext cx="5467657" cy="1102032"/>
+            <a:chOff x="1902903" y="1539099"/>
+            <a:chExt cx="6374162" cy="1438410"/>
           </a:xfrm>
         </p:grpSpPr>
-        <p:grpSp>
-          <p:nvGrpSpPr>
-            <p:cNvPr id="22" name="Group 21">
+        <p:pic>
+          <p:nvPicPr>
+            <p:cNvPr id="30" name="Picture 29" descr="A screenshot of a chat&#10;&#10;Description automatically generated">
               <a:extLst>
                 <a:ext uri="{FF2B5EF4-FFF2-40B4-BE49-F238E27FC236}">
-                  <a16:creationId xmlns:a16="http://schemas.microsoft.com/office/drawing/2014/main" id="{02D140D8-836C-EE48-CE5D-D00BA26F0A1E}"/>
+                  <a16:creationId xmlns:a16="http://schemas.microsoft.com/office/drawing/2014/main" id="{A7D2A6C3-2DE9-E72E-9861-BCF0F5C9F764}"/>
                 </a:ext>
               </a:extLst>
             </p:cNvPr>
-            <p:cNvGrpSpPr/>
+            <p:cNvPicPr>
+              <a:picLocks noChangeAspect="1"/>
+            </p:cNvPicPr>
             <p:nvPr/>
-          </p:nvGrpSpPr>
-          <p:grpSpPr>
+          </p:nvPicPr>
+          <p:blipFill>
+            <a:blip r:embed="rId5"/>
+            <a:srcRect b="81512"/>
+            <a:stretch/>
+          </p:blipFill>
+          <p:spPr>
             <a:xfrm>
-              <a:off x="5190816" y="1219780"/>
-              <a:ext cx="5810559" cy="5639614"/>
-              <a:chOff x="5190816" y="1219780"/>
-              <a:chExt cx="5810559" cy="5639614"/>
+              <a:off x="1902903" y="1539099"/>
+              <a:ext cx="6362700" cy="392113"/>
             </a:xfrm>
-          </p:grpSpPr>
-          <p:grpSp>
-            <p:nvGrpSpPr>
-              <p:cNvPr id="24" name="Group 23">
-                <a:extLst>
-                  <a:ext uri="{FF2B5EF4-FFF2-40B4-BE49-F238E27FC236}">
-                    <a16:creationId xmlns:a16="http://schemas.microsoft.com/office/drawing/2014/main" id="{41F6846A-C4D0-7241-F688-E72994E5FF44}"/>
-                  </a:ext>
-                </a:extLst>
-              </p:cNvPr>
-              <p:cNvGrpSpPr/>
-              <p:nvPr/>
-            </p:nvGrpSpPr>
-            <p:grpSpPr>
-              <a:xfrm>
-                <a:off x="5379783" y="1219780"/>
-                <a:ext cx="5467657" cy="1102032"/>
-                <a:chOff x="1902903" y="1539099"/>
-                <a:chExt cx="6374162" cy="1438410"/>
-              </a:xfrm>
-            </p:grpSpPr>
-            <p:pic>
-              <p:nvPicPr>
-                <p:cNvPr id="30" name="Picture 29" descr="A screenshot of a chat&#10;&#10;Description automatically generated">
-                  <a:extLst>
-                    <a:ext uri="{FF2B5EF4-FFF2-40B4-BE49-F238E27FC236}">
-                      <a16:creationId xmlns:a16="http://schemas.microsoft.com/office/drawing/2014/main" id="{A7D2A6C3-2DE9-E72E-9861-BCF0F5C9F764}"/>
-                    </a:ext>
-                  </a:extLst>
-                </p:cNvPr>
-                <p:cNvPicPr>
-                  <a:picLocks noChangeAspect="1"/>
-                </p:cNvPicPr>
-                <p:nvPr/>
-              </p:nvPicPr>
-              <p:blipFill>
-                <a:blip r:embed="rId5"/>
-                <a:srcRect b="81512"/>
-                <a:stretch/>
-              </p:blipFill>
-              <p:spPr>
-                <a:xfrm>
-                  <a:off x="1902903" y="1539099"/>
-                  <a:ext cx="6362700" cy="392113"/>
-                </a:xfrm>
-                <a:prstGeom prst="rect">
-                  <a:avLst/>
-                </a:prstGeom>
-              </p:spPr>
-            </p:pic>
-            <p:pic>
-              <p:nvPicPr>
-                <p:cNvPr id="31" name="Picture 30" descr="A screenshot of a chat&#10;&#10;Description automatically generated">
-                  <a:extLst>
-                    <a:ext uri="{FF2B5EF4-FFF2-40B4-BE49-F238E27FC236}">
-                      <a16:creationId xmlns:a16="http://schemas.microsoft.com/office/drawing/2014/main" id="{76928AC6-DC16-A99B-07F4-93FB54B0E3BB}"/>
-                    </a:ext>
-                  </a:extLst>
-                </p:cNvPr>
-                <p:cNvPicPr>
-                  <a:picLocks noChangeAspect="1"/>
-                </p:cNvPicPr>
-                <p:nvPr/>
-              </p:nvPicPr>
-              <p:blipFill>
-                <a:blip r:embed="rId5"/>
-                <a:srcRect t="50898"/>
-                <a:stretch/>
-              </p:blipFill>
-              <p:spPr>
-                <a:xfrm>
-                  <a:off x="1914365" y="1936109"/>
-                  <a:ext cx="6362700" cy="1041400"/>
-                </a:xfrm>
-                <a:prstGeom prst="rect">
-                  <a:avLst/>
-                </a:prstGeom>
-              </p:spPr>
-            </p:pic>
-          </p:grpSp>
-          <p:pic>
-            <p:nvPicPr>
-              <p:cNvPr id="25" name="Picture 24" descr="A screenshot of a chat&#10;&#10;Description automatically generated">
-                <a:extLst>
-                  <a:ext uri="{FF2B5EF4-FFF2-40B4-BE49-F238E27FC236}">
-                    <a16:creationId xmlns:a16="http://schemas.microsoft.com/office/drawing/2014/main" id="{3C3AB251-B4B1-2E21-D274-8CA5432E851E}"/>
-                  </a:ext>
-                </a:extLst>
-              </p:cNvPr>
-              <p:cNvPicPr>
-                <a:picLocks noChangeAspect="1"/>
-              </p:cNvPicPr>
-              <p:nvPr/>
-            </p:nvPicPr>
-            <p:blipFill>
-              <a:blip r:embed="rId6"/>
-              <a:stretch>
-                <a:fillRect/>
-              </a:stretch>
-            </p:blipFill>
-            <p:spPr>
-              <a:xfrm>
-                <a:off x="5339555" y="2276382"/>
-                <a:ext cx="5557045" cy="2264799"/>
-              </a:xfrm>
-              <a:prstGeom prst="rect">
-                <a:avLst/>
-              </a:prstGeom>
-            </p:spPr>
-          </p:pic>
-          <p:grpSp>
-            <p:nvGrpSpPr>
-              <p:cNvPr id="26" name="Group 25">
-                <a:extLst>
-                  <a:ext uri="{FF2B5EF4-FFF2-40B4-BE49-F238E27FC236}">
-                    <a16:creationId xmlns:a16="http://schemas.microsoft.com/office/drawing/2014/main" id="{DEE52295-F28A-FEB5-34B9-E86F1446C571}"/>
-                  </a:ext>
-                </a:extLst>
-              </p:cNvPr>
-              <p:cNvGrpSpPr/>
-              <p:nvPr/>
-            </p:nvGrpSpPr>
-            <p:grpSpPr>
-              <a:xfrm>
-                <a:off x="5190816" y="4477188"/>
-                <a:ext cx="5810559" cy="1062701"/>
-                <a:chOff x="2732222" y="4562834"/>
-                <a:chExt cx="6487978" cy="1193898"/>
-              </a:xfrm>
-            </p:grpSpPr>
-            <p:pic>
-              <p:nvPicPr>
-                <p:cNvPr id="28" name="Picture 27" descr="A screenshot of a chat&#10;&#10;Description automatically generated">
-                  <a:extLst>
-                    <a:ext uri="{FF2B5EF4-FFF2-40B4-BE49-F238E27FC236}">
-                      <a16:creationId xmlns:a16="http://schemas.microsoft.com/office/drawing/2014/main" id="{8D153652-D2C9-917F-7A96-0DB4E9D7933D}"/>
-                    </a:ext>
-                  </a:extLst>
-                </p:cNvPr>
-                <p:cNvPicPr>
-                  <a:picLocks noChangeAspect="1"/>
-                </p:cNvPicPr>
-                <p:nvPr/>
-              </p:nvPicPr>
-              <p:blipFill>
-                <a:blip r:embed="rId7"/>
-                <a:srcRect t="75146"/>
-                <a:stretch/>
-              </p:blipFill>
-              <p:spPr>
-                <a:xfrm>
-                  <a:off x="2743200" y="4977085"/>
-                  <a:ext cx="6477000" cy="779647"/>
-                </a:xfrm>
-                <a:prstGeom prst="rect">
-                  <a:avLst/>
-                </a:prstGeom>
-              </p:spPr>
-            </p:pic>
-            <p:pic>
-              <p:nvPicPr>
-                <p:cNvPr id="29" name="Picture 28">
-                  <a:extLst>
-                    <a:ext uri="{FF2B5EF4-FFF2-40B4-BE49-F238E27FC236}">
-                      <a16:creationId xmlns:a16="http://schemas.microsoft.com/office/drawing/2014/main" id="{691E57B1-CD81-259B-26DC-FD276070399A}"/>
-                    </a:ext>
-                  </a:extLst>
-                </p:cNvPr>
-                <p:cNvPicPr>
-                  <a:picLocks noChangeAspect="1"/>
-                </p:cNvPicPr>
-                <p:nvPr/>
-              </p:nvPicPr>
-              <p:blipFill>
-                <a:blip r:embed="rId7"/>
-                <a:srcRect b="85738"/>
-                <a:stretch/>
-              </p:blipFill>
-              <p:spPr>
-                <a:xfrm>
-                  <a:off x="2732222" y="4562834"/>
-                  <a:ext cx="6477000" cy="447391"/>
-                </a:xfrm>
-                <a:prstGeom prst="rect">
-                  <a:avLst/>
-                </a:prstGeom>
-              </p:spPr>
-            </p:pic>
-          </p:grpSp>
-          <p:pic>
-            <p:nvPicPr>
-              <p:cNvPr id="27" name="Picture 26" descr="A screenshot of a computer&#10;&#10;Description automatically generated">
-                <a:extLst>
-                  <a:ext uri="{FF2B5EF4-FFF2-40B4-BE49-F238E27FC236}">
-                    <a16:creationId xmlns:a16="http://schemas.microsoft.com/office/drawing/2014/main" id="{C71F94C9-A015-8571-6967-880AD71EB167}"/>
-                  </a:ext>
-                </a:extLst>
-              </p:cNvPr>
-              <p:cNvPicPr>
-                <a:picLocks noChangeAspect="1"/>
-              </p:cNvPicPr>
-              <p:nvPr/>
-            </p:nvPicPr>
-            <p:blipFill>
-              <a:blip r:embed="rId8"/>
-              <a:stretch>
-                <a:fillRect/>
-              </a:stretch>
-            </p:blipFill>
-            <p:spPr>
-              <a:xfrm>
-                <a:off x="5257800" y="5948932"/>
-                <a:ext cx="5586415" cy="910462"/>
-              </a:xfrm>
-              <a:prstGeom prst="rect">
-                <a:avLst/>
-              </a:prstGeom>
-            </p:spPr>
-          </p:pic>
-        </p:grpSp>
+            <a:prstGeom prst="rect">
+              <a:avLst/>
+            </a:prstGeom>
+          </p:spPr>
+        </p:pic>
+        <p:pic>
+          <p:nvPicPr>
+            <p:cNvPr id="31" name="Picture 30" descr="A screenshot of a chat&#10;&#10;Description automatically generated">
+              <a:extLst>
+                <a:ext uri="{FF2B5EF4-FFF2-40B4-BE49-F238E27FC236}">
+                  <a16:creationId xmlns:a16="http://schemas.microsoft.com/office/drawing/2014/main" id="{76928AC6-DC16-A99B-07F4-93FB54B0E3BB}"/>
+                </a:ext>
+              </a:extLst>
+            </p:cNvPr>
+            <p:cNvPicPr>
+              <a:picLocks noChangeAspect="1"/>
+            </p:cNvPicPr>
+            <p:nvPr/>
+          </p:nvPicPr>
+          <p:blipFill>
+            <a:blip r:embed="rId5"/>
+            <a:srcRect t="50898"/>
+            <a:stretch/>
+          </p:blipFill>
+          <p:spPr>
+            <a:xfrm>
+              <a:off x="1914365" y="1936109"/>
+              <a:ext cx="6362700" cy="1041400"/>
+            </a:xfrm>
+            <a:prstGeom prst="rect">
+              <a:avLst/>
+            </a:prstGeom>
+          </p:spPr>
+        </p:pic>
+      </p:grpSp>
+      <p:grpSp>
+        <p:nvGrpSpPr>
+          <p:cNvPr id="20" name="Group 19">
+            <a:extLst>
+              <a:ext uri="{FF2B5EF4-FFF2-40B4-BE49-F238E27FC236}">
+                <a16:creationId xmlns:a16="http://schemas.microsoft.com/office/drawing/2014/main" id="{80312099-335A-1767-6FBB-A05C9ED1B840}"/>
+              </a:ext>
+            </a:extLst>
+          </p:cNvPr>
+          <p:cNvGrpSpPr/>
+          <p:nvPr/>
+        </p:nvGrpSpPr>
+        <p:grpSpPr>
+          <a:xfrm>
+            <a:off x="6092850" y="4357850"/>
+            <a:ext cx="5810559" cy="1423501"/>
+            <a:chOff x="6127376" y="4381665"/>
+            <a:chExt cx="5810559" cy="1423501"/>
+          </a:xfrm>
+        </p:grpSpPr>
         <p:pic>
           <p:nvPicPr>
             <p:cNvPr id="23" name="Picture 22">
@@ -23100,14 +23100,14 @@
             <p:nvPr/>
           </p:nvPicPr>
           <p:blipFill>
-            <a:blip r:embed="rId9"/>
+            <a:blip r:embed="rId6"/>
             <a:stretch>
               <a:fillRect/>
             </a:stretch>
           </p:blipFill>
           <p:spPr>
             <a:xfrm>
-              <a:off x="5638800" y="5506989"/>
+              <a:off x="6575360" y="5411466"/>
               <a:ext cx="4114800" cy="393700"/>
             </a:xfrm>
             <a:prstGeom prst="rect">
@@ -23115,13 +23115,187 @@
             </a:prstGeom>
           </p:spPr>
         </p:pic>
+        <p:grpSp>
+          <p:nvGrpSpPr>
+            <p:cNvPr id="26" name="Group 25">
+              <a:extLst>
+                <a:ext uri="{FF2B5EF4-FFF2-40B4-BE49-F238E27FC236}">
+                  <a16:creationId xmlns:a16="http://schemas.microsoft.com/office/drawing/2014/main" id="{DEE52295-F28A-FEB5-34B9-E86F1446C571}"/>
+                </a:ext>
+              </a:extLst>
+            </p:cNvPr>
+            <p:cNvGrpSpPr/>
+            <p:nvPr/>
+          </p:nvGrpSpPr>
+          <p:grpSpPr>
+            <a:xfrm>
+              <a:off x="6127376" y="4381665"/>
+              <a:ext cx="5810559" cy="1062701"/>
+              <a:chOff x="2732222" y="4562834"/>
+              <a:chExt cx="6487978" cy="1193898"/>
+            </a:xfrm>
+          </p:grpSpPr>
+          <p:pic>
+            <p:nvPicPr>
+              <p:cNvPr id="28" name="Picture 27" descr="A screenshot of a chat&#10;&#10;Description automatically generated">
+                <a:extLst>
+                  <a:ext uri="{FF2B5EF4-FFF2-40B4-BE49-F238E27FC236}">
+                    <a16:creationId xmlns:a16="http://schemas.microsoft.com/office/drawing/2014/main" id="{8D153652-D2C9-917F-7A96-0DB4E9D7933D}"/>
+                  </a:ext>
+                </a:extLst>
+              </p:cNvPr>
+              <p:cNvPicPr>
+                <a:picLocks noChangeAspect="1"/>
+              </p:cNvPicPr>
+              <p:nvPr/>
+            </p:nvPicPr>
+            <p:blipFill>
+              <a:blip r:embed="rId7"/>
+              <a:srcRect t="75146"/>
+              <a:stretch/>
+            </p:blipFill>
+            <p:spPr>
+              <a:xfrm>
+                <a:off x="2743200" y="4977085"/>
+                <a:ext cx="6477000" cy="779647"/>
+              </a:xfrm>
+              <a:prstGeom prst="rect">
+                <a:avLst/>
+              </a:prstGeom>
+            </p:spPr>
+          </p:pic>
+          <p:pic>
+            <p:nvPicPr>
+              <p:cNvPr id="29" name="Picture 28">
+                <a:extLst>
+                  <a:ext uri="{FF2B5EF4-FFF2-40B4-BE49-F238E27FC236}">
+                    <a16:creationId xmlns:a16="http://schemas.microsoft.com/office/drawing/2014/main" id="{691E57B1-CD81-259B-26DC-FD276070399A}"/>
+                  </a:ext>
+                </a:extLst>
+              </p:cNvPr>
+              <p:cNvPicPr>
+                <a:picLocks noChangeAspect="1"/>
+              </p:cNvPicPr>
+              <p:nvPr/>
+            </p:nvPicPr>
+            <p:blipFill>
+              <a:blip r:embed="rId7"/>
+              <a:srcRect b="85738"/>
+              <a:stretch/>
+            </p:blipFill>
+            <p:spPr>
+              <a:xfrm>
+                <a:off x="2732222" y="4562834"/>
+                <a:ext cx="6477000" cy="447391"/>
+              </a:xfrm>
+              <a:prstGeom prst="rect">
+                <a:avLst/>
+              </a:prstGeom>
+            </p:spPr>
+          </p:pic>
+        </p:grpSp>
       </p:grpSp>
+      <p:pic>
+        <p:nvPicPr>
+          <p:cNvPr id="27" name="Picture 26" descr="A screenshot of a computer&#10;&#10;Description automatically generated">
+            <a:extLst>
+              <a:ext uri="{FF2B5EF4-FFF2-40B4-BE49-F238E27FC236}">
+                <a16:creationId xmlns:a16="http://schemas.microsoft.com/office/drawing/2014/main" id="{C71F94C9-A015-8571-6967-880AD71EB167}"/>
+              </a:ext>
+            </a:extLst>
+          </p:cNvPr>
+          <p:cNvPicPr>
+            <a:picLocks noChangeAspect="1"/>
+          </p:cNvPicPr>
+          <p:nvPr/>
+        </p:nvPicPr>
+        <p:blipFill>
+          <a:blip r:embed="rId8"/>
+          <a:stretch>
+            <a:fillRect/>
+          </a:stretch>
+        </p:blipFill>
+        <p:spPr>
+          <a:xfrm>
+            <a:off x="6102682" y="5832497"/>
+            <a:ext cx="5586415" cy="910462"/>
+          </a:xfrm>
+          <a:prstGeom prst="rect">
+            <a:avLst/>
+          </a:prstGeom>
+        </p:spPr>
+      </p:pic>
+      <p:sp>
+        <p:nvSpPr>
+          <p:cNvPr id="48" name="TextBox 47">
+            <a:extLst>
+              <a:ext uri="{FF2B5EF4-FFF2-40B4-BE49-F238E27FC236}">
+                <a16:creationId xmlns:a16="http://schemas.microsoft.com/office/drawing/2014/main" id="{5F497387-0C43-CE5C-E73E-CA2C0FBF25ED}"/>
+              </a:ext>
+            </a:extLst>
+          </p:cNvPr>
+          <p:cNvSpPr txBox="1"/>
+          <p:nvPr/>
+        </p:nvSpPr>
+        <p:spPr>
+          <a:xfrm>
+            <a:off x="6671160" y="943361"/>
+            <a:ext cx="1563033" cy="338554"/>
+          </a:xfrm>
+          <a:prstGeom prst="rect">
+            <a:avLst/>
+          </a:prstGeom>
+          <a:noFill/>
+        </p:spPr>
+        <p:txBody>
+          <a:bodyPr wrap="square" rtlCol="0">
+            <a:spAutoFit/>
+          </a:bodyPr>
+          <a:lstStyle/>
+          <a:p>
+            <a:r>
+              <a:rPr lang="en-US" sz="1600" dirty="0"/>
+              <a:t>PR author</a:t>
+            </a:r>
+          </a:p>
+        </p:txBody>
+      </p:sp>
+      <p:pic>
+        <p:nvPicPr>
+          <p:cNvPr id="9" name="Picture 8" descr="A screenshot of a chat&#10;&#10;Description automatically generated">
+            <a:extLst>
+              <a:ext uri="{FF2B5EF4-FFF2-40B4-BE49-F238E27FC236}">
+                <a16:creationId xmlns:a16="http://schemas.microsoft.com/office/drawing/2014/main" id="{7113677A-E2CE-1310-423C-6752B12E3EC5}"/>
+              </a:ext>
+            </a:extLst>
+          </p:cNvPr>
+          <p:cNvPicPr>
+            <a:picLocks noChangeAspect="1"/>
+          </p:cNvPicPr>
+          <p:nvPr/>
+        </p:nvPicPr>
+        <p:blipFill>
+          <a:blip r:embed="rId9"/>
+          <a:stretch>
+            <a:fillRect/>
+          </a:stretch>
+        </p:blipFill>
+        <p:spPr>
+          <a:xfrm>
+            <a:off x="6219608" y="2171578"/>
+            <a:ext cx="5557045" cy="2264799"/>
+          </a:xfrm>
+          <a:prstGeom prst="rect">
+            <a:avLst/>
+          </a:prstGeom>
+        </p:spPr>
+      </p:pic>
       <p:grpSp>
         <p:nvGrpSpPr>
-          <p:cNvPr id="35" name="Group 34">
+          <p:cNvPr id="11" name="Group 10">
             <a:extLst>
               <a:ext uri="{FF2B5EF4-FFF2-40B4-BE49-F238E27FC236}">
-                <a16:creationId xmlns:a16="http://schemas.microsoft.com/office/drawing/2014/main" id="{BD735505-15FA-1981-EF08-4F182072B1EA}"/>
+                <a16:creationId xmlns:a16="http://schemas.microsoft.com/office/drawing/2014/main" id="{DAA0C12B-A522-73C5-786C-082FEAF4D2C6}"/>
               </a:ext>
             </a:extLst>
           </p:cNvPr>
@@ -23130,94 +23304,311 @@
         </p:nvGrpSpPr>
         <p:grpSpPr>
           <a:xfrm>
-            <a:off x="8923204" y="3522242"/>
-            <a:ext cx="2845278" cy="441002"/>
-            <a:chOff x="8051322" y="3474202"/>
-            <a:chExt cx="2845278" cy="441002"/>
+            <a:off x="6671160" y="2120155"/>
+            <a:ext cx="5097322" cy="1843089"/>
+            <a:chOff x="6671160" y="2120155"/>
+            <a:chExt cx="5097322" cy="1843089"/>
           </a:xfrm>
         </p:grpSpPr>
-        <p:pic>
-          <p:nvPicPr>
-            <p:cNvPr id="36" name="Picture 35">
+        <p:grpSp>
+          <p:nvGrpSpPr>
+            <p:cNvPr id="12" name="Group 11">
               <a:extLst>
                 <a:ext uri="{FF2B5EF4-FFF2-40B4-BE49-F238E27FC236}">
-                  <a16:creationId xmlns:a16="http://schemas.microsoft.com/office/drawing/2014/main" id="{2CAB456B-2E9A-9A96-D1F2-46553209B72E}"/>
+                  <a16:creationId xmlns:a16="http://schemas.microsoft.com/office/drawing/2014/main" id="{5776378E-4F65-F6BA-A5FA-A7B10B84FAAC}"/>
                 </a:ext>
               </a:extLst>
             </p:cNvPr>
-            <p:cNvPicPr>
-              <a:picLocks noChangeAspect="1"/>
-            </p:cNvPicPr>
+            <p:cNvGrpSpPr/>
             <p:nvPr/>
-          </p:nvPicPr>
-          <p:blipFill>
-            <a:blip r:embed="rId10"/>
-            <a:stretch>
-              <a:fillRect/>
-            </a:stretch>
-          </p:blipFill>
+          </p:nvGrpSpPr>
+          <p:grpSpPr>
+            <a:xfrm>
+              <a:off x="8923204" y="3522242"/>
+              <a:ext cx="2845278" cy="441002"/>
+              <a:chOff x="8051322" y="3474202"/>
+              <a:chExt cx="2845278" cy="441002"/>
+            </a:xfrm>
+          </p:grpSpPr>
+          <p:pic>
+            <p:nvPicPr>
+              <p:cNvPr id="17" name="Picture 16">
+                <a:extLst>
+                  <a:ext uri="{FF2B5EF4-FFF2-40B4-BE49-F238E27FC236}">
+                    <a16:creationId xmlns:a16="http://schemas.microsoft.com/office/drawing/2014/main" id="{F87D5D29-3B2B-296A-A73D-02CFD0BC8AE3}"/>
+                  </a:ext>
+                </a:extLst>
+              </p:cNvPr>
+              <p:cNvPicPr>
+                <a:picLocks noChangeAspect="1"/>
+              </p:cNvPicPr>
+              <p:nvPr/>
+            </p:nvPicPr>
+            <p:blipFill>
+              <a:blip r:embed="rId10"/>
+              <a:stretch>
+                <a:fillRect/>
+              </a:stretch>
+            </p:blipFill>
+            <p:spPr>
+              <a:xfrm>
+                <a:off x="8051322" y="3680887"/>
+                <a:ext cx="2845278" cy="234317"/>
+              </a:xfrm>
+              <a:prstGeom prst="rect">
+                <a:avLst/>
+              </a:prstGeom>
+            </p:spPr>
+          </p:pic>
+          <p:cxnSp>
+            <p:nvCxnSpPr>
+              <p:cNvPr id="18" name="Straight Arrow Connector 17">
+                <a:extLst>
+                  <a:ext uri="{FF2B5EF4-FFF2-40B4-BE49-F238E27FC236}">
+                    <a16:creationId xmlns:a16="http://schemas.microsoft.com/office/drawing/2014/main" id="{646868AA-6A82-16B0-CAAE-5DB22CDF8CDB}"/>
+                  </a:ext>
+                </a:extLst>
+              </p:cNvPr>
+              <p:cNvCxnSpPr>
+                <a:cxnSpLocks/>
+                <a:stCxn id="17" idx="0"/>
+              </p:cNvCxnSpPr>
+              <p:nvPr/>
+            </p:nvCxnSpPr>
+            <p:spPr>
+              <a:xfrm flipH="1" flipV="1">
+                <a:off x="8440355" y="3474202"/>
+                <a:ext cx="1033606" cy="206685"/>
+              </a:xfrm>
+              <a:prstGeom prst="straightConnector1">
+                <a:avLst/>
+              </a:prstGeom>
+              <a:ln w="28575">
+                <a:solidFill>
+                  <a:srgbClr val="C00000"/>
+                </a:solidFill>
+                <a:tailEnd type="triangle"/>
+              </a:ln>
+            </p:spPr>
+            <p:style>
+              <a:lnRef idx="1">
+                <a:schemeClr val="accent1"/>
+              </a:lnRef>
+              <a:fillRef idx="0">
+                <a:schemeClr val="accent1"/>
+              </a:fillRef>
+              <a:effectRef idx="0">
+                <a:schemeClr val="accent1"/>
+              </a:effectRef>
+              <a:fontRef idx="minor">
+                <a:schemeClr val="tx1"/>
+              </a:fontRef>
+            </p:style>
+          </p:cxnSp>
+        </p:grpSp>
+        <p:grpSp>
+          <p:nvGrpSpPr>
+            <p:cNvPr id="13" name="Group 12">
+              <a:extLst>
+                <a:ext uri="{FF2B5EF4-FFF2-40B4-BE49-F238E27FC236}">
+                  <a16:creationId xmlns:a16="http://schemas.microsoft.com/office/drawing/2014/main" id="{44D61698-1A25-B3EF-B1C6-F0A16F84AF91}"/>
+                </a:ext>
+              </a:extLst>
+            </p:cNvPr>
+            <p:cNvGrpSpPr/>
+            <p:nvPr/>
+          </p:nvGrpSpPr>
+          <p:grpSpPr>
+            <a:xfrm>
+              <a:off x="6671160" y="2714301"/>
+              <a:ext cx="3682180" cy="1044883"/>
+              <a:chOff x="5799278" y="2666261"/>
+              <a:chExt cx="3682180" cy="1044883"/>
+            </a:xfrm>
+          </p:grpSpPr>
+          <p:sp>
+            <p:nvSpPr>
+              <p:cNvPr id="15" name="Rounded Rectangle 14">
+                <a:extLst>
+                  <a:ext uri="{FF2B5EF4-FFF2-40B4-BE49-F238E27FC236}">
+                    <a16:creationId xmlns:a16="http://schemas.microsoft.com/office/drawing/2014/main" id="{4C17517E-6047-EC4A-F6ED-9BF03AFC15FE}"/>
+                  </a:ext>
+                </a:extLst>
+              </p:cNvPr>
+              <p:cNvSpPr/>
+              <p:nvPr/>
+            </p:nvSpPr>
+            <p:spPr>
+              <a:xfrm>
+                <a:off x="5799278" y="2666261"/>
+                <a:ext cx="3682180" cy="349030"/>
+              </a:xfrm>
+              <a:prstGeom prst="roundRect">
+                <a:avLst/>
+              </a:prstGeom>
+              <a:noFill/>
+              <a:ln w="12700">
+                <a:solidFill>
+                  <a:srgbClr val="C00000"/>
+                </a:solidFill>
+              </a:ln>
+            </p:spPr>
+            <p:style>
+              <a:lnRef idx="2">
+                <a:schemeClr val="accent1">
+                  <a:shade val="15000"/>
+                </a:schemeClr>
+              </a:lnRef>
+              <a:fillRef idx="1">
+                <a:schemeClr val="accent1"/>
+              </a:fillRef>
+              <a:effectRef idx="0">
+                <a:schemeClr val="accent1"/>
+              </a:effectRef>
+              <a:fontRef idx="minor">
+                <a:schemeClr val="lt1"/>
+              </a:fontRef>
+            </p:style>
+            <p:txBody>
+              <a:bodyPr rtlCol="0" anchor="ctr"/>
+              <a:lstStyle/>
+              <a:p>
+                <a:pPr algn="ctr"/>
+                <a:endParaRPr lang="en-US"/>
+              </a:p>
+            </p:txBody>
+          </p:sp>
+          <p:sp>
+            <p:nvSpPr>
+              <p:cNvPr id="16" name="Rounded Rectangle 15">
+                <a:extLst>
+                  <a:ext uri="{FF2B5EF4-FFF2-40B4-BE49-F238E27FC236}">
+                    <a16:creationId xmlns:a16="http://schemas.microsoft.com/office/drawing/2014/main" id="{E2B1DEA9-FFED-ADBB-4EFC-FEB34DEB4EB9}"/>
+                  </a:ext>
+                </a:extLst>
+              </p:cNvPr>
+              <p:cNvSpPr/>
+              <p:nvPr/>
+            </p:nvSpPr>
+            <p:spPr>
+              <a:xfrm>
+                <a:off x="5799278" y="3476762"/>
+                <a:ext cx="2246670" cy="234382"/>
+              </a:xfrm>
+              <a:prstGeom prst="roundRect">
+                <a:avLst/>
+              </a:prstGeom>
+              <a:noFill/>
+              <a:ln w="12700">
+                <a:solidFill>
+                  <a:srgbClr val="C00000"/>
+                </a:solidFill>
+              </a:ln>
+            </p:spPr>
+            <p:style>
+              <a:lnRef idx="2">
+                <a:schemeClr val="accent1">
+                  <a:shade val="15000"/>
+                </a:schemeClr>
+              </a:lnRef>
+              <a:fillRef idx="1">
+                <a:schemeClr val="accent1"/>
+              </a:fillRef>
+              <a:effectRef idx="0">
+                <a:schemeClr val="accent1"/>
+              </a:effectRef>
+              <a:fontRef idx="minor">
+                <a:schemeClr val="lt1"/>
+              </a:fontRef>
+            </p:style>
+            <p:txBody>
+              <a:bodyPr rtlCol="0" anchor="ctr"/>
+              <a:lstStyle/>
+              <a:p>
+                <a:pPr algn="ctr"/>
+                <a:endParaRPr lang="en-US"/>
+              </a:p>
+            </p:txBody>
+          </p:sp>
+        </p:grpSp>
+        <p:sp>
+          <p:nvSpPr>
+            <p:cNvPr id="14" name="TextBox 13">
+              <a:extLst>
+                <a:ext uri="{FF2B5EF4-FFF2-40B4-BE49-F238E27FC236}">
+                  <a16:creationId xmlns:a16="http://schemas.microsoft.com/office/drawing/2014/main" id="{41C0D84E-3B4B-ECA0-ECD8-C7AC04943867}"/>
+                </a:ext>
+              </a:extLst>
+            </p:cNvPr>
+            <p:cNvSpPr txBox="1"/>
+            <p:nvPr/>
+          </p:nvSpPr>
           <p:spPr>
             <a:xfrm>
-              <a:off x="8051322" y="3680887"/>
-              <a:ext cx="2845278" cy="234317"/>
+              <a:off x="8493091" y="2120155"/>
+              <a:ext cx="1524968" cy="338554"/>
             </a:xfrm>
             <a:prstGeom prst="rect">
               <a:avLst/>
             </a:prstGeom>
+            <a:noFill/>
           </p:spPr>
-        </p:pic>
-        <p:cxnSp>
-          <p:nvCxnSpPr>
-            <p:cNvPr id="37" name="Straight Arrow Connector 36">
-              <a:extLst>
-                <a:ext uri="{FF2B5EF4-FFF2-40B4-BE49-F238E27FC236}">
-                  <a16:creationId xmlns:a16="http://schemas.microsoft.com/office/drawing/2014/main" id="{C88FD154-328F-0ED7-574F-D218F35A23AE}"/>
-                </a:ext>
-              </a:extLst>
-            </p:cNvPr>
-            <p:cNvCxnSpPr>
-              <a:cxnSpLocks/>
-              <a:stCxn id="36" idx="0"/>
-            </p:cNvCxnSpPr>
-            <p:nvPr/>
-          </p:nvCxnSpPr>
-          <p:spPr>
-            <a:xfrm flipH="1" flipV="1">
-              <a:off x="8440355" y="3474202"/>
-              <a:ext cx="1033606" cy="206685"/>
-            </a:xfrm>
-            <a:prstGeom prst="straightConnector1">
-              <a:avLst/>
-            </a:prstGeom>
-            <a:ln w="28575">
-              <a:solidFill>
-                <a:srgbClr val="C00000"/>
-              </a:solidFill>
-              <a:tailEnd type="triangle"/>
-            </a:ln>
-          </p:spPr>
-          <p:style>
-            <a:lnRef idx="1">
-              <a:schemeClr val="accent1"/>
-            </a:lnRef>
-            <a:fillRef idx="0">
-              <a:schemeClr val="accent1"/>
-            </a:fillRef>
-            <a:effectRef idx="0">
-              <a:schemeClr val="accent1"/>
-            </a:effectRef>
-            <a:fontRef idx="minor">
-              <a:schemeClr val="tx1"/>
-            </a:fontRef>
-          </p:style>
-        </p:cxnSp>
+          <p:txBody>
+            <a:bodyPr wrap="square" rtlCol="0">
+              <a:spAutoFit/>
+            </a:bodyPr>
+            <a:lstStyle/>
+            <a:p>
+              <a:r>
+                <a:rPr lang="en-US" sz="1600" dirty="0"/>
+                <a:t>maintainer</a:t>
+              </a:r>
+            </a:p>
+          </p:txBody>
+        </p:sp>
       </p:grpSp>
       <p:sp>
         <p:nvSpPr>
-          <p:cNvPr id="38" name="Rounded Rectangle 37">
+          <p:cNvPr id="32" name="TextBox 31">
             <a:extLst>
               <a:ext uri="{FF2B5EF4-FFF2-40B4-BE49-F238E27FC236}">
-                <a16:creationId xmlns:a16="http://schemas.microsoft.com/office/drawing/2014/main" id="{5340E0A9-84CF-8390-701E-8872116C68CF}"/>
+                <a16:creationId xmlns:a16="http://schemas.microsoft.com/office/drawing/2014/main" id="{D0C02D86-0553-9F04-23FC-E7D9626A4EDA}"/>
+              </a:ext>
+            </a:extLst>
+          </p:cNvPr>
+          <p:cNvSpPr txBox="1"/>
+          <p:nvPr/>
+        </p:nvSpPr>
+        <p:spPr>
+          <a:xfrm>
+            <a:off x="7027395" y="5052566"/>
+            <a:ext cx="3736988" cy="307777"/>
+          </a:xfrm>
+          <a:prstGeom prst="rect">
+            <a:avLst/>
+          </a:prstGeom>
+          <a:noFill/>
+        </p:spPr>
+        <p:txBody>
+          <a:bodyPr wrap="square">
+            <a:spAutoFit/>
+          </a:bodyPr>
+          <a:lstStyle/>
+          <a:p>
+            <a:r>
+              <a:rPr lang="en-GB" sz="1400" dirty="0"/>
+              <a:t>Refined Code (After ChatGPT’s Suggestion)</a:t>
+            </a:r>
+            <a:endParaRPr lang="en-US" sz="1400" dirty="0"/>
+          </a:p>
+        </p:txBody>
+      </p:sp>
+      <p:sp>
+        <p:nvSpPr>
+          <p:cNvPr id="52" name="Rounded Rectangle 51">
+            <a:extLst>
+              <a:ext uri="{FF2B5EF4-FFF2-40B4-BE49-F238E27FC236}">
+                <a16:creationId xmlns:a16="http://schemas.microsoft.com/office/drawing/2014/main" id="{34D990EE-A111-D76D-90C5-2402DCCADA36}"/>
               </a:ext>
             </a:extLst>
           </p:cNvPr>
@@ -23226,14 +23617,14 @@
         </p:nvSpPr>
         <p:spPr>
           <a:xfrm>
-            <a:off x="6702412" y="1424673"/>
-            <a:ext cx="3677264" cy="442333"/>
+            <a:off x="6671160" y="1343818"/>
+            <a:ext cx="3827507" cy="364391"/>
           </a:xfrm>
           <a:prstGeom prst="roundRect">
             <a:avLst/>
           </a:prstGeom>
           <a:noFill/>
-          <a:ln w="12700">
+          <a:ln>
             <a:solidFill>
               <a:srgbClr val="C00000"/>
             </a:solidFill>
@@ -23261,414 +23652,6 @@
           <a:p>
             <a:pPr algn="ctr"/>
             <a:endParaRPr lang="en-US"/>
-          </a:p>
-        </p:txBody>
-      </p:sp>
-      <p:sp>
-        <p:nvSpPr>
-          <p:cNvPr id="39" name="Rounded Rectangle 38">
-            <a:extLst>
-              <a:ext uri="{FF2B5EF4-FFF2-40B4-BE49-F238E27FC236}">
-                <a16:creationId xmlns:a16="http://schemas.microsoft.com/office/drawing/2014/main" id="{D2AEC5DA-A889-D840-E04C-FF6EB1B01097}"/>
-              </a:ext>
-            </a:extLst>
-          </p:cNvPr>
-          <p:cNvSpPr/>
-          <p:nvPr/>
-        </p:nvSpPr>
-        <p:spPr>
-          <a:xfrm>
-            <a:off x="6569674" y="4749659"/>
-            <a:ext cx="2168013" cy="304850"/>
-          </a:xfrm>
-          <a:prstGeom prst="roundRect">
-            <a:avLst/>
-          </a:prstGeom>
-          <a:noFill/>
-          <a:ln w="12700">
-            <a:solidFill>
-              <a:srgbClr val="C00000"/>
-            </a:solidFill>
-          </a:ln>
-        </p:spPr>
-        <p:style>
-          <a:lnRef idx="2">
-            <a:schemeClr val="accent1">
-              <a:shade val="15000"/>
-            </a:schemeClr>
-          </a:lnRef>
-          <a:fillRef idx="1">
-            <a:schemeClr val="accent1"/>
-          </a:fillRef>
-          <a:effectRef idx="0">
-            <a:schemeClr val="accent1"/>
-          </a:effectRef>
-          <a:fontRef idx="minor">
-            <a:schemeClr val="lt1"/>
-          </a:fontRef>
-        </p:style>
-        <p:txBody>
-          <a:bodyPr rtlCol="0" anchor="ctr"/>
-          <a:lstStyle/>
-          <a:p>
-            <a:pPr algn="ctr"/>
-            <a:endParaRPr lang="en-US"/>
-          </a:p>
-        </p:txBody>
-      </p:sp>
-      <p:grpSp>
-        <p:nvGrpSpPr>
-          <p:cNvPr id="40" name="Group 39">
-            <a:extLst>
-              <a:ext uri="{FF2B5EF4-FFF2-40B4-BE49-F238E27FC236}">
-                <a16:creationId xmlns:a16="http://schemas.microsoft.com/office/drawing/2014/main" id="{6EF694E5-B34C-4C1A-A863-6C4AC4CDE64A}"/>
-              </a:ext>
-            </a:extLst>
-          </p:cNvPr>
-          <p:cNvGrpSpPr/>
-          <p:nvPr/>
-        </p:nvGrpSpPr>
-        <p:grpSpPr>
-          <a:xfrm>
-            <a:off x="6781068" y="5888383"/>
-            <a:ext cx="3774873" cy="624937"/>
-            <a:chOff x="5860026" y="5840343"/>
-            <a:chExt cx="3774873" cy="624937"/>
-          </a:xfrm>
-        </p:grpSpPr>
-        <p:sp>
-          <p:nvSpPr>
-            <p:cNvPr id="41" name="Rounded Rectangle 40">
-              <a:extLst>
-                <a:ext uri="{FF2B5EF4-FFF2-40B4-BE49-F238E27FC236}">
-                  <a16:creationId xmlns:a16="http://schemas.microsoft.com/office/drawing/2014/main" id="{D3F8E0B3-18D0-ECF8-5A83-B7287F16797E}"/>
-                </a:ext>
-              </a:extLst>
-            </p:cNvPr>
-            <p:cNvSpPr/>
-            <p:nvPr/>
-          </p:nvSpPr>
-          <p:spPr>
-            <a:xfrm>
-              <a:off x="5860026" y="5840343"/>
-              <a:ext cx="2300748" cy="269682"/>
-            </a:xfrm>
-            <a:prstGeom prst="roundRect">
-              <a:avLst/>
-            </a:prstGeom>
-            <a:noFill/>
-            <a:ln w="12700">
-              <a:solidFill>
-                <a:srgbClr val="C00000"/>
-              </a:solidFill>
-            </a:ln>
-          </p:spPr>
-          <p:style>
-            <a:lnRef idx="2">
-              <a:schemeClr val="accent1">
-                <a:shade val="15000"/>
-              </a:schemeClr>
-            </a:lnRef>
-            <a:fillRef idx="1">
-              <a:schemeClr val="accent1"/>
-            </a:fillRef>
-            <a:effectRef idx="0">
-              <a:schemeClr val="accent1"/>
-            </a:effectRef>
-            <a:fontRef idx="minor">
-              <a:schemeClr val="lt1"/>
-            </a:fontRef>
-          </p:style>
-          <p:txBody>
-            <a:bodyPr rtlCol="0" anchor="ctr"/>
-            <a:lstStyle/>
-            <a:p>
-              <a:pPr algn="ctr"/>
-              <a:endParaRPr lang="en-US"/>
-            </a:p>
-          </p:txBody>
-        </p:sp>
-        <p:sp>
-          <p:nvSpPr>
-            <p:cNvPr id="42" name="Rounded Rectangle 41">
-              <a:extLst>
-                <a:ext uri="{FF2B5EF4-FFF2-40B4-BE49-F238E27FC236}">
-                  <a16:creationId xmlns:a16="http://schemas.microsoft.com/office/drawing/2014/main" id="{643FB4E8-CA45-8DC6-EC26-1EA2B19B6E7A}"/>
-                </a:ext>
-              </a:extLst>
-            </p:cNvPr>
-            <p:cNvSpPr/>
-            <p:nvPr/>
-          </p:nvSpPr>
-          <p:spPr>
-            <a:xfrm>
-              <a:off x="6002594" y="6295575"/>
-              <a:ext cx="3632305" cy="169705"/>
-            </a:xfrm>
-            <a:prstGeom prst="roundRect">
-              <a:avLst/>
-            </a:prstGeom>
-            <a:noFill/>
-            <a:ln w="12700">
-              <a:solidFill>
-                <a:srgbClr val="C00000"/>
-              </a:solidFill>
-            </a:ln>
-          </p:spPr>
-          <p:style>
-            <a:lnRef idx="2">
-              <a:schemeClr val="accent1">
-                <a:shade val="15000"/>
-              </a:schemeClr>
-            </a:lnRef>
-            <a:fillRef idx="1">
-              <a:schemeClr val="accent1"/>
-            </a:fillRef>
-            <a:effectRef idx="0">
-              <a:schemeClr val="accent1"/>
-            </a:effectRef>
-            <a:fontRef idx="minor">
-              <a:schemeClr val="lt1"/>
-            </a:fontRef>
-          </p:style>
-          <p:txBody>
-            <a:bodyPr rtlCol="0" anchor="ctr"/>
-            <a:lstStyle/>
-            <a:p>
-              <a:pPr algn="ctr"/>
-              <a:endParaRPr lang="en-US" dirty="0"/>
-            </a:p>
-          </p:txBody>
-        </p:sp>
-      </p:grpSp>
-      <p:grpSp>
-        <p:nvGrpSpPr>
-          <p:cNvPr id="43" name="Group 42">
-            <a:extLst>
-              <a:ext uri="{FF2B5EF4-FFF2-40B4-BE49-F238E27FC236}">
-                <a16:creationId xmlns:a16="http://schemas.microsoft.com/office/drawing/2014/main" id="{C6332E32-63BF-6900-65A1-7AA478FFACC0}"/>
-              </a:ext>
-            </a:extLst>
-          </p:cNvPr>
-          <p:cNvGrpSpPr/>
-          <p:nvPr/>
-        </p:nvGrpSpPr>
-        <p:grpSpPr>
-          <a:xfrm>
-            <a:off x="6671160" y="2714301"/>
-            <a:ext cx="3682180" cy="1044883"/>
-            <a:chOff x="5799278" y="2666261"/>
-            <a:chExt cx="3682180" cy="1044883"/>
-          </a:xfrm>
-        </p:grpSpPr>
-        <p:sp>
-          <p:nvSpPr>
-            <p:cNvPr id="44" name="Rounded Rectangle 43">
-              <a:extLst>
-                <a:ext uri="{FF2B5EF4-FFF2-40B4-BE49-F238E27FC236}">
-                  <a16:creationId xmlns:a16="http://schemas.microsoft.com/office/drawing/2014/main" id="{B7595BB2-3EE4-9BC2-A4ED-1754A450CD50}"/>
-                </a:ext>
-              </a:extLst>
-            </p:cNvPr>
-            <p:cNvSpPr/>
-            <p:nvPr/>
-          </p:nvSpPr>
-          <p:spPr>
-            <a:xfrm>
-              <a:off x="5799278" y="2666261"/>
-              <a:ext cx="3682180" cy="349030"/>
-            </a:xfrm>
-            <a:prstGeom prst="roundRect">
-              <a:avLst/>
-            </a:prstGeom>
-            <a:noFill/>
-            <a:ln w="12700">
-              <a:solidFill>
-                <a:srgbClr val="C00000"/>
-              </a:solidFill>
-            </a:ln>
-          </p:spPr>
-          <p:style>
-            <a:lnRef idx="2">
-              <a:schemeClr val="accent1">
-                <a:shade val="15000"/>
-              </a:schemeClr>
-            </a:lnRef>
-            <a:fillRef idx="1">
-              <a:schemeClr val="accent1"/>
-            </a:fillRef>
-            <a:effectRef idx="0">
-              <a:schemeClr val="accent1"/>
-            </a:effectRef>
-            <a:fontRef idx="minor">
-              <a:schemeClr val="lt1"/>
-            </a:fontRef>
-          </p:style>
-          <p:txBody>
-            <a:bodyPr rtlCol="0" anchor="ctr"/>
-            <a:lstStyle/>
-            <a:p>
-              <a:pPr algn="ctr"/>
-              <a:endParaRPr lang="en-US"/>
-            </a:p>
-          </p:txBody>
-        </p:sp>
-        <p:sp>
-          <p:nvSpPr>
-            <p:cNvPr id="45" name="Rounded Rectangle 44">
-              <a:extLst>
-                <a:ext uri="{FF2B5EF4-FFF2-40B4-BE49-F238E27FC236}">
-                  <a16:creationId xmlns:a16="http://schemas.microsoft.com/office/drawing/2014/main" id="{F8863316-7CAC-A7BA-83D1-E7EC4B4091C4}"/>
-                </a:ext>
-              </a:extLst>
-            </p:cNvPr>
-            <p:cNvSpPr/>
-            <p:nvPr/>
-          </p:nvSpPr>
-          <p:spPr>
-            <a:xfrm>
-              <a:off x="5799278" y="3476762"/>
-              <a:ext cx="2246670" cy="234382"/>
-            </a:xfrm>
-            <a:prstGeom prst="roundRect">
-              <a:avLst/>
-            </a:prstGeom>
-            <a:noFill/>
-            <a:ln w="12700">
-              <a:solidFill>
-                <a:srgbClr val="C00000"/>
-              </a:solidFill>
-            </a:ln>
-          </p:spPr>
-          <p:style>
-            <a:lnRef idx="2">
-              <a:schemeClr val="accent1">
-                <a:shade val="15000"/>
-              </a:schemeClr>
-            </a:lnRef>
-            <a:fillRef idx="1">
-              <a:schemeClr val="accent1"/>
-            </a:fillRef>
-            <a:effectRef idx="0">
-              <a:schemeClr val="accent1"/>
-            </a:effectRef>
-            <a:fontRef idx="minor">
-              <a:schemeClr val="lt1"/>
-            </a:fontRef>
-          </p:style>
-          <p:txBody>
-            <a:bodyPr rtlCol="0" anchor="ctr"/>
-            <a:lstStyle/>
-            <a:p>
-              <a:pPr algn="ctr"/>
-              <a:endParaRPr lang="en-US"/>
-            </a:p>
-          </p:txBody>
-        </p:sp>
-      </p:grpSp>
-      <p:sp>
-        <p:nvSpPr>
-          <p:cNvPr id="46" name="TextBox 45">
-            <a:extLst>
-              <a:ext uri="{FF2B5EF4-FFF2-40B4-BE49-F238E27FC236}">
-                <a16:creationId xmlns:a16="http://schemas.microsoft.com/office/drawing/2014/main" id="{1CA459E2-4A1A-8FD0-10DE-E8ABAD03A563}"/>
-              </a:ext>
-            </a:extLst>
-          </p:cNvPr>
-          <p:cNvSpPr txBox="1"/>
-          <p:nvPr/>
-        </p:nvSpPr>
-        <p:spPr>
-          <a:xfrm>
-            <a:off x="7387081" y="5136849"/>
-            <a:ext cx="3736988" cy="307777"/>
-          </a:xfrm>
-          <a:prstGeom prst="rect">
-            <a:avLst/>
-          </a:prstGeom>
-          <a:noFill/>
-        </p:spPr>
-        <p:txBody>
-          <a:bodyPr wrap="square">
-            <a:spAutoFit/>
-          </a:bodyPr>
-          <a:lstStyle/>
-          <a:p>
-            <a:r>
-              <a:rPr lang="en-GB" sz="1400" dirty="0"/>
-              <a:t>Refined Code (After ChatGPT’s Suggestion)</a:t>
-            </a:r>
-            <a:endParaRPr lang="en-US" sz="1400" dirty="0"/>
-          </a:p>
-        </p:txBody>
-      </p:sp>
-      <p:sp>
-        <p:nvSpPr>
-          <p:cNvPr id="47" name="TextBox 46">
-            <a:extLst>
-              <a:ext uri="{FF2B5EF4-FFF2-40B4-BE49-F238E27FC236}">
-                <a16:creationId xmlns:a16="http://schemas.microsoft.com/office/drawing/2014/main" id="{9A9EC4BB-59F5-32C2-B039-EBE887A5F9D3}"/>
-              </a:ext>
-            </a:extLst>
-          </p:cNvPr>
-          <p:cNvSpPr txBox="1"/>
-          <p:nvPr/>
-        </p:nvSpPr>
-        <p:spPr>
-          <a:xfrm>
-            <a:off x="8493091" y="2120155"/>
-            <a:ext cx="1524968" cy="369332"/>
-          </a:xfrm>
-          <a:prstGeom prst="rect">
-            <a:avLst/>
-          </a:prstGeom>
-          <a:noFill/>
-        </p:spPr>
-        <p:txBody>
-          <a:bodyPr wrap="square" rtlCol="0">
-            <a:spAutoFit/>
-          </a:bodyPr>
-          <a:lstStyle/>
-          <a:p>
-            <a:r>
-              <a:rPr lang="en-US" dirty="0"/>
-              <a:t>maintainer</a:t>
-            </a:r>
-          </a:p>
-        </p:txBody>
-      </p:sp>
-      <p:sp>
-        <p:nvSpPr>
-          <p:cNvPr id="48" name="TextBox 47">
-            <a:extLst>
-              <a:ext uri="{FF2B5EF4-FFF2-40B4-BE49-F238E27FC236}">
-                <a16:creationId xmlns:a16="http://schemas.microsoft.com/office/drawing/2014/main" id="{5F497387-0C43-CE5C-E73E-CA2C0FBF25ED}"/>
-              </a:ext>
-            </a:extLst>
-          </p:cNvPr>
-          <p:cNvSpPr txBox="1"/>
-          <p:nvPr/>
-        </p:nvSpPr>
-        <p:spPr>
-          <a:xfrm>
-            <a:off x="8782810" y="1061692"/>
-            <a:ext cx="1088960" cy="369332"/>
-          </a:xfrm>
-          <a:prstGeom prst="rect">
-            <a:avLst/>
-          </a:prstGeom>
-          <a:noFill/>
-        </p:spPr>
-        <p:txBody>
-          <a:bodyPr wrap="square" rtlCol="0">
-            <a:spAutoFit/>
-          </a:bodyPr>
-          <a:lstStyle/>
-          <a:p>
-            <a:r>
-              <a:rPr lang="en-US" dirty="0"/>
-              <a:t>reviewer</a:t>
-            </a:r>
           </a:p>
         </p:txBody>
       </p:sp>
@@ -23703,7 +23686,7 @@
                             </p:stCondLst>
                             <p:childTnLst>
                               <p:par>
-                                <p:cTn id="5" presetID="1" presetClass="entr" presetSubtype="0" fill="hold" grpId="0" nodeType="clickEffect">
+                                <p:cTn id="5" presetID="1" presetClass="entr" presetSubtype="0" fill="hold" nodeType="clickEffect">
                                   <p:stCondLst>
                                     <p:cond delay="0"/>
                                   </p:stCondLst>
@@ -23716,7 +23699,88 @@
                                           </p:stCondLst>
                                         </p:cTn>
                                         <p:tgtEl>
-                                          <p:spTgt spid="38"/>
+                                          <p:spTgt spid="24"/>
+                                        </p:tgtEl>
+                                        <p:attrNameLst>
+                                          <p:attrName>style.visibility</p:attrName>
+                                        </p:attrNameLst>
+                                      </p:cBhvr>
+                                      <p:to>
+                                        <p:strVal val="visible"/>
+                                      </p:to>
+                                    </p:set>
+                                  </p:childTnLst>
+                                </p:cTn>
+                              </p:par>
+                              <p:par>
+                                <p:cTn id="7" presetID="1" presetClass="entr" presetSubtype="0" fill="hold" grpId="0" nodeType="withEffect">
+                                  <p:stCondLst>
+                                    <p:cond delay="0"/>
+                                  </p:stCondLst>
+                                  <p:childTnLst>
+                                    <p:set>
+                                      <p:cBhvr>
+                                        <p:cTn id="8" dur="1" fill="hold">
+                                          <p:stCondLst>
+                                            <p:cond delay="0"/>
+                                          </p:stCondLst>
+                                        </p:cTn>
+                                        <p:tgtEl>
+                                          <p:spTgt spid="48"/>
+                                        </p:tgtEl>
+                                        <p:attrNameLst>
+                                          <p:attrName>style.visibility</p:attrName>
+                                        </p:attrNameLst>
+                                      </p:cBhvr>
+                                      <p:to>
+                                        <p:strVal val="visible"/>
+                                      </p:to>
+                                    </p:set>
+                                  </p:childTnLst>
+                                </p:cTn>
+                              </p:par>
+                              <p:par>
+                                <p:cTn id="9" presetID="1" presetClass="entr" presetSubtype="0" fill="hold" grpId="0" nodeType="withEffect">
+                                  <p:stCondLst>
+                                    <p:cond delay="0"/>
+                                  </p:stCondLst>
+                                  <p:childTnLst>
+                                    <p:set>
+                                      <p:cBhvr>
+                                        <p:cTn id="10" dur="1" fill="hold">
+                                          <p:stCondLst>
+                                            <p:cond delay="0"/>
+                                          </p:stCondLst>
+                                        </p:cTn>
+                                        <p:tgtEl>
+                                          <p:spTgt spid="52"/>
+                                        </p:tgtEl>
+                                        <p:attrNameLst>
+                                          <p:attrName>style.visibility</p:attrName>
+                                        </p:attrNameLst>
+                                      </p:cBhvr>
+                                      <p:to>
+                                        <p:strVal val="visible"/>
+                                      </p:to>
+                                    </p:set>
+                                  </p:childTnLst>
+                                </p:cTn>
+                              </p:par>
+                              <p:par>
+                                <p:cTn id="11" presetID="1" presetClass="entr" presetSubtype="0" fill="hold" nodeType="withEffect">
+                                  <p:stCondLst>
+                                    <p:cond delay="0"/>
+                                  </p:stCondLst>
+                                  <p:childTnLst>
+                                    <p:set>
+                                      <p:cBhvr>
+                                        <p:cTn id="12" dur="1" fill="hold">
+                                          <p:stCondLst>
+                                            <p:cond delay="0"/>
+                                          </p:stCondLst>
+                                        </p:cTn>
+                                        <p:tgtEl>
+                                          <p:spTgt spid="4"/>
                                         </p:tgtEl>
                                         <p:attrNameLst>
                                           <p:attrName>style.visibility</p:attrName>
@@ -23736,32 +23800,32 @@
                     </p:cTn>
                   </p:par>
                   <p:par>
-                    <p:cTn id="7" fill="hold">
+                    <p:cTn id="13" fill="hold">
                       <p:stCondLst>
                         <p:cond delay="indefinite"/>
                       </p:stCondLst>
                       <p:childTnLst>
                         <p:par>
-                          <p:cTn id="8" fill="hold">
+                          <p:cTn id="14" fill="hold">
                             <p:stCondLst>
                               <p:cond delay="0"/>
                             </p:stCondLst>
                             <p:childTnLst>
                               <p:par>
-                                <p:cTn id="9" presetID="1" presetClass="entr" presetSubtype="0" fill="hold" nodeType="clickEffect">
+                                <p:cTn id="15" presetID="1" presetClass="entr" presetSubtype="0" fill="hold" nodeType="clickEffect">
                                   <p:stCondLst>
                                     <p:cond delay="0"/>
                                   </p:stCondLst>
                                   <p:childTnLst>
                                     <p:set>
                                       <p:cBhvr>
-                                        <p:cTn id="10" dur="1" fill="hold">
+                                        <p:cTn id="16" dur="1" fill="hold">
                                           <p:stCondLst>
                                             <p:cond delay="0"/>
                                           </p:stCondLst>
                                         </p:cTn>
                                         <p:tgtEl>
-                                          <p:spTgt spid="43"/>
+                                          <p:spTgt spid="9"/>
                                         </p:tgtEl>
                                         <p:attrNameLst>
                                           <p:attrName>style.visibility</p:attrName>
@@ -23774,71 +23838,8 @@
                                   </p:childTnLst>
                                 </p:cTn>
                               </p:par>
-                            </p:childTnLst>
-                          </p:cTn>
-                        </p:par>
-                      </p:childTnLst>
-                    </p:cTn>
-                  </p:par>
-                  <p:par>
-                    <p:cTn id="11" fill="hold">
-                      <p:stCondLst>
-                        <p:cond delay="indefinite"/>
-                      </p:stCondLst>
-                      <p:childTnLst>
-                        <p:par>
-                          <p:cTn id="12" fill="hold">
-                            <p:stCondLst>
-                              <p:cond delay="0"/>
-                            </p:stCondLst>
-                            <p:childTnLst>
                               <p:par>
-                                <p:cTn id="13" presetID="1" presetClass="entr" presetSubtype="0" fill="hold" nodeType="clickEffect">
-                                  <p:stCondLst>
-                                    <p:cond delay="0"/>
-                                  </p:stCondLst>
-                                  <p:childTnLst>
-                                    <p:set>
-                                      <p:cBhvr>
-                                        <p:cTn id="14" dur="1" fill="hold">
-                                          <p:stCondLst>
-                                            <p:cond delay="0"/>
-                                          </p:stCondLst>
-                                        </p:cTn>
-                                        <p:tgtEl>
-                                          <p:spTgt spid="35"/>
-                                        </p:tgtEl>
-                                        <p:attrNameLst>
-                                          <p:attrName>style.visibility</p:attrName>
-                                        </p:attrNameLst>
-                                      </p:cBhvr>
-                                      <p:to>
-                                        <p:strVal val="visible"/>
-                                      </p:to>
-                                    </p:set>
-                                  </p:childTnLst>
-                                </p:cTn>
-                              </p:par>
-                            </p:childTnLst>
-                          </p:cTn>
-                        </p:par>
-                      </p:childTnLst>
-                    </p:cTn>
-                  </p:par>
-                  <p:par>
-                    <p:cTn id="15" fill="hold">
-                      <p:stCondLst>
-                        <p:cond delay="indefinite"/>
-                      </p:stCondLst>
-                      <p:childTnLst>
-                        <p:par>
-                          <p:cTn id="16" fill="hold">
-                            <p:stCondLst>
-                              <p:cond delay="0"/>
-                            </p:stCondLst>
-                            <p:childTnLst>
-                              <p:par>
-                                <p:cTn id="17" presetID="1" presetClass="entr" presetSubtype="0" fill="hold" grpId="0" nodeType="clickEffect">
+                                <p:cTn id="17" presetID="1" presetClass="entr" presetSubtype="0" fill="hold" nodeType="withEffect">
                                   <p:stCondLst>
                                     <p:cond delay="0"/>
                                   </p:stCondLst>
@@ -23851,7 +23852,7 @@
                                           </p:stCondLst>
                                         </p:cTn>
                                         <p:tgtEl>
-                                          <p:spTgt spid="39"/>
+                                          <p:spTgt spid="11"/>
                                         </p:tgtEl>
                                         <p:attrNameLst>
                                           <p:attrName>style.visibility</p:attrName>
@@ -23883,7 +23884,7 @@
                             </p:stCondLst>
                             <p:childTnLst>
                               <p:par>
-                                <p:cTn id="21" presetID="1" presetClass="entr" presetSubtype="0" fill="hold" grpId="0" nodeType="clickEffect">
+                                <p:cTn id="21" presetID="1" presetClass="entr" presetSubtype="0" fill="hold" nodeType="clickEffect">
                                   <p:stCondLst>
                                     <p:cond delay="0"/>
                                   </p:stCondLst>
@@ -23896,7 +23897,34 @@
                                           </p:stCondLst>
                                         </p:cTn>
                                         <p:tgtEl>
-                                          <p:spTgt spid="46"/>
+                                          <p:spTgt spid="20"/>
+                                        </p:tgtEl>
+                                        <p:attrNameLst>
+                                          <p:attrName>style.visibility</p:attrName>
+                                        </p:attrNameLst>
+                                      </p:cBhvr>
+                                      <p:to>
+                                        <p:strVal val="visible"/>
+                                      </p:to>
+                                    </p:set>
+                                  </p:childTnLst>
+                                </p:cTn>
+                              </p:par>
+                              <p:par>
+                                <p:cTn id="23" presetID="1" presetClass="entr" presetSubtype="0" fill="hold" grpId="0" nodeType="withEffect">
+                                  <p:stCondLst>
+                                    <p:cond delay="0"/>
+                                  </p:stCondLst>
+                                  <p:childTnLst>
+                                    <p:set>
+                                      <p:cBhvr>
+                                        <p:cTn id="24" dur="1" fill="hold">
+                                          <p:stCondLst>
+                                            <p:cond delay="0"/>
+                                          </p:stCondLst>
+                                        </p:cTn>
+                                        <p:tgtEl>
+                                          <p:spTgt spid="32"/>
                                         </p:tgtEl>
                                         <p:attrNameLst>
                                           <p:attrName>style.visibility</p:attrName>
@@ -23916,32 +23944,32 @@
                     </p:cTn>
                   </p:par>
                   <p:par>
-                    <p:cTn id="23" fill="hold">
+                    <p:cTn id="25" fill="hold">
                       <p:stCondLst>
                         <p:cond delay="indefinite"/>
                       </p:stCondLst>
                       <p:childTnLst>
                         <p:par>
-                          <p:cTn id="24" fill="hold">
+                          <p:cTn id="26" fill="hold">
                             <p:stCondLst>
                               <p:cond delay="0"/>
                             </p:stCondLst>
                             <p:childTnLst>
                               <p:par>
-                                <p:cTn id="25" presetID="1" presetClass="entr" presetSubtype="0" fill="hold" nodeType="clickEffect">
+                                <p:cTn id="27" presetID="1" presetClass="entr" presetSubtype="0" fill="hold" nodeType="clickEffect">
                                   <p:stCondLst>
                                     <p:cond delay="0"/>
                                   </p:stCondLst>
                                   <p:childTnLst>
                                     <p:set>
                                       <p:cBhvr>
-                                        <p:cTn id="26" dur="1" fill="hold">
+                                        <p:cTn id="28" dur="1" fill="hold">
                                           <p:stCondLst>
                                             <p:cond delay="0"/>
                                           </p:stCondLst>
                                         </p:cTn>
                                         <p:tgtEl>
-                                          <p:spTgt spid="40"/>
+                                          <p:spTgt spid="27"/>
                                         </p:tgtEl>
                                         <p:attrNameLst>
                                           <p:attrName>style.visibility</p:attrName>
@@ -23982,9 +24010,9 @@
       </p:par>
     </p:tnLst>
     <p:bldLst>
-      <p:bldP spid="38" grpId="0" animBg="1"/>
-      <p:bldP spid="39" grpId="0" animBg="1"/>
-      <p:bldP spid="46" grpId="0"/>
+      <p:bldP spid="48" grpId="0"/>
+      <p:bldP spid="32" grpId="0"/>
+      <p:bldP spid="52" grpId="0" animBg="1"/>
     </p:bldLst>
   </p:timing>
 </p:sld>
@@ -24028,7 +24056,7 @@
         <p:spPr>
           <a:xfrm>
             <a:off x="134471" y="1210237"/>
-            <a:ext cx="6092483" cy="4739759"/>
+            <a:ext cx="6092483" cy="4401205"/>
           </a:xfrm>
           <a:prstGeom prst="rect">
             <a:avLst/>
@@ -24050,6 +24078,29 @@
                 <a:latin typeface="Arial" panose="020B0604020202020204" pitchFamily="34" charset="0"/>
                 <a:cs typeface="Arial" panose="020B0604020202020204" pitchFamily="34" charset="0"/>
               </a:rPr>
+              <a:t>Justification</a:t>
+            </a:r>
+          </a:p>
+          <a:p>
+            <a:pPr marL="742950" lvl="1" indent="-285750">
+              <a:buFontTx/>
+              <a:buChar char="-"/>
+            </a:pPr>
+            <a:r>
+              <a:rPr lang="en-GB" dirty="0"/>
+              <a:t>The author explains the reasoning and updates code accordingly.</a:t>
+            </a:r>
+          </a:p>
+          <a:p>
+            <a:pPr marL="285750" indent="-285750">
+              <a:buFontTx/>
+              <a:buChar char="-"/>
+            </a:pPr>
+            <a:r>
+              <a:rPr lang="en-US" sz="2800" dirty="0">
+                <a:latin typeface="Arial" panose="020B0604020202020204" pitchFamily="34" charset="0"/>
+                <a:cs typeface="Arial" panose="020B0604020202020204" pitchFamily="34" charset="0"/>
+              </a:rPr>
               <a:t>Verification</a:t>
             </a:r>
           </a:p>
@@ -24065,33 +24116,6 @@
               </a:rPr>
               <a:t>Maintainer checks official Laravel docs.</a:t>
             </a:r>
-            <a:endParaRPr lang="en-US" sz="2200" dirty="0">
-              <a:latin typeface="Arial" panose="020B0604020202020204" pitchFamily="34" charset="0"/>
-              <a:cs typeface="Arial" panose="020B0604020202020204" pitchFamily="34" charset="0"/>
-            </a:endParaRPr>
-          </a:p>
-          <a:p>
-            <a:pPr marL="285750" indent="-285750">
-              <a:buFontTx/>
-              <a:buChar char="-"/>
-            </a:pPr>
-            <a:r>
-              <a:rPr lang="en-US" sz="2800" dirty="0">
-                <a:latin typeface="Arial" panose="020B0604020202020204" pitchFamily="34" charset="0"/>
-                <a:cs typeface="Arial" panose="020B0604020202020204" pitchFamily="34" charset="0"/>
-              </a:rPr>
-              <a:t>Justification</a:t>
-            </a:r>
-          </a:p>
-          <a:p>
-            <a:pPr marL="742950" lvl="1" indent="-285750">
-              <a:buFontTx/>
-              <a:buChar char="-"/>
-            </a:pPr>
-            <a:r>
-              <a:rPr lang="en-GB" dirty="0"/>
-              <a:t>The developer explains the reasoning and updates code accordingly.</a:t>
-            </a:r>
             <a:endParaRPr lang="en-US" dirty="0">
               <a:latin typeface="Arial" panose="020B0604020202020204" pitchFamily="34" charset="0"/>
               <a:cs typeface="Arial" panose="020B0604020202020204" pitchFamily="34" charset="0"/>
@@ -24165,16 +24189,6 @@
             <a:r>
               <a:rPr lang="en-GB" sz="2200" dirty="0"/>
               <a:t>refined change is visible in commit history.</a:t>
-            </a:r>
-          </a:p>
-          <a:p>
-            <a:pPr marL="742950" lvl="1" indent="-285750">
-              <a:buFontTx/>
-              <a:buChar char="-"/>
-            </a:pPr>
-            <a:r>
-              <a:rPr lang="en-GB" sz="2200" dirty="0"/>
-              <a:t>merge commit references the discussion.</a:t>
             </a:r>
           </a:p>
         </p:txBody>
@@ -24671,131 +24685,6 @@
       </p:sp>
       <p:grpSp>
         <p:nvGrpSpPr>
-          <p:cNvPr id="49" name="Group 48">
-            <a:extLst>
-              <a:ext uri="{FF2B5EF4-FFF2-40B4-BE49-F238E27FC236}">
-                <a16:creationId xmlns:a16="http://schemas.microsoft.com/office/drawing/2014/main" id="{E7EEB2D2-9F89-6BFA-E6CE-36D6AC1F683F}"/>
-              </a:ext>
-            </a:extLst>
-          </p:cNvPr>
-          <p:cNvGrpSpPr/>
-          <p:nvPr/>
-        </p:nvGrpSpPr>
-        <p:grpSpPr>
-          <a:xfrm>
-            <a:off x="6781068" y="5888383"/>
-            <a:ext cx="3774873" cy="624937"/>
-            <a:chOff x="5860026" y="5840343"/>
-            <a:chExt cx="3774873" cy="624937"/>
-          </a:xfrm>
-        </p:grpSpPr>
-        <p:sp>
-          <p:nvSpPr>
-            <p:cNvPr id="50" name="Rounded Rectangle 49">
-              <a:extLst>
-                <a:ext uri="{FF2B5EF4-FFF2-40B4-BE49-F238E27FC236}">
-                  <a16:creationId xmlns:a16="http://schemas.microsoft.com/office/drawing/2014/main" id="{08F59F01-9085-CB37-844B-4250F09D9548}"/>
-                </a:ext>
-              </a:extLst>
-            </p:cNvPr>
-            <p:cNvSpPr/>
-            <p:nvPr/>
-          </p:nvSpPr>
-          <p:spPr>
-            <a:xfrm>
-              <a:off x="5860026" y="5840343"/>
-              <a:ext cx="2300748" cy="269682"/>
-            </a:xfrm>
-            <a:prstGeom prst="roundRect">
-              <a:avLst/>
-            </a:prstGeom>
-            <a:noFill/>
-            <a:ln w="12700">
-              <a:solidFill>
-                <a:srgbClr val="C00000"/>
-              </a:solidFill>
-            </a:ln>
-          </p:spPr>
-          <p:style>
-            <a:lnRef idx="2">
-              <a:schemeClr val="accent1">
-                <a:shade val="15000"/>
-              </a:schemeClr>
-            </a:lnRef>
-            <a:fillRef idx="1">
-              <a:schemeClr val="accent1"/>
-            </a:fillRef>
-            <a:effectRef idx="0">
-              <a:schemeClr val="accent1"/>
-            </a:effectRef>
-            <a:fontRef idx="minor">
-              <a:schemeClr val="lt1"/>
-            </a:fontRef>
-          </p:style>
-          <p:txBody>
-            <a:bodyPr rtlCol="0" anchor="ctr"/>
-            <a:lstStyle/>
-            <a:p>
-              <a:pPr algn="ctr"/>
-              <a:endParaRPr lang="en-US"/>
-            </a:p>
-          </p:txBody>
-        </p:sp>
-        <p:sp>
-          <p:nvSpPr>
-            <p:cNvPr id="51" name="Rounded Rectangle 50">
-              <a:extLst>
-                <a:ext uri="{FF2B5EF4-FFF2-40B4-BE49-F238E27FC236}">
-                  <a16:creationId xmlns:a16="http://schemas.microsoft.com/office/drawing/2014/main" id="{E6DB69E0-5C02-9E01-6135-81EC7B4DECD6}"/>
-                </a:ext>
-              </a:extLst>
-            </p:cNvPr>
-            <p:cNvSpPr/>
-            <p:nvPr/>
-          </p:nvSpPr>
-          <p:spPr>
-            <a:xfrm>
-              <a:off x="6002594" y="6295575"/>
-              <a:ext cx="3632305" cy="169705"/>
-            </a:xfrm>
-            <a:prstGeom prst="roundRect">
-              <a:avLst/>
-            </a:prstGeom>
-            <a:noFill/>
-            <a:ln w="12700">
-              <a:solidFill>
-                <a:srgbClr val="C00000"/>
-              </a:solidFill>
-            </a:ln>
-          </p:spPr>
-          <p:style>
-            <a:lnRef idx="2">
-              <a:schemeClr val="accent1">
-                <a:shade val="15000"/>
-              </a:schemeClr>
-            </a:lnRef>
-            <a:fillRef idx="1">
-              <a:schemeClr val="accent1"/>
-            </a:fillRef>
-            <a:effectRef idx="0">
-              <a:schemeClr val="accent1"/>
-            </a:effectRef>
-            <a:fontRef idx="minor">
-              <a:schemeClr val="lt1"/>
-            </a:fontRef>
-          </p:style>
-          <p:txBody>
-            <a:bodyPr rtlCol="0" anchor="ctr"/>
-            <a:lstStyle/>
-            <a:p>
-              <a:pPr algn="ctr"/>
-              <a:endParaRPr lang="en-US" dirty="0"/>
-            </a:p>
-          </p:txBody>
-        </p:sp>
-      </p:grpSp>
-      <p:grpSp>
-        <p:nvGrpSpPr>
           <p:cNvPr id="52" name="Group 51">
             <a:extLst>
               <a:ext uri="{FF2B5EF4-FFF2-40B4-BE49-F238E27FC236}">
@@ -24998,10 +24887,10 @@
       </p:sp>
       <p:sp>
         <p:nvSpPr>
-          <p:cNvPr id="59" name="TextBox 58">
+          <p:cNvPr id="60" name="TextBox 59">
             <a:extLst>
               <a:ext uri="{FF2B5EF4-FFF2-40B4-BE49-F238E27FC236}">
-                <a16:creationId xmlns:a16="http://schemas.microsoft.com/office/drawing/2014/main" id="{D3455D77-B037-951B-B39A-95C11C81C72B}"/>
+                <a16:creationId xmlns:a16="http://schemas.microsoft.com/office/drawing/2014/main" id="{B5334C37-3CD7-5CD2-81BC-453E652E748C}"/>
               </a:ext>
             </a:extLst>
           </p:cNvPr>
@@ -25010,8 +24899,8 @@
         </p:nvSpPr>
         <p:spPr>
           <a:xfrm>
-            <a:off x="8782810" y="1061692"/>
-            <a:ext cx="1088960" cy="369332"/>
+            <a:off x="8493091" y="2120155"/>
+            <a:ext cx="1524968" cy="338554"/>
           </a:xfrm>
           <a:prstGeom prst="rect">
             <a:avLst/>
@@ -25025,18 +24914,18 @@
           <a:lstStyle/>
           <a:p>
             <a:r>
-              <a:rPr lang="en-US" dirty="0"/>
-              <a:t>reviewer</a:t>
+              <a:rPr lang="en-US" sz="1600" dirty="0"/>
+              <a:t>maintainer</a:t>
             </a:r>
           </a:p>
         </p:txBody>
       </p:sp>
       <p:sp>
         <p:nvSpPr>
-          <p:cNvPr id="60" name="TextBox 59">
+          <p:cNvPr id="61" name="TextBox 60">
             <a:extLst>
               <a:ext uri="{FF2B5EF4-FFF2-40B4-BE49-F238E27FC236}">
-                <a16:creationId xmlns:a16="http://schemas.microsoft.com/office/drawing/2014/main" id="{B5334C37-3CD7-5CD2-81BC-453E652E748C}"/>
+                <a16:creationId xmlns:a16="http://schemas.microsoft.com/office/drawing/2014/main" id="{F5AC231C-922F-0CEC-D9FF-17784B31BFCD}"/>
               </a:ext>
             </a:extLst>
           </p:cNvPr>
@@ -25045,8 +24934,51 @@
         </p:nvSpPr>
         <p:spPr>
           <a:xfrm>
-            <a:off x="8493091" y="2120155"/>
-            <a:ext cx="1524968" cy="369332"/>
+            <a:off x="227024" y="5853409"/>
+            <a:ext cx="5868976" cy="707886"/>
+          </a:xfrm>
+          <a:prstGeom prst="rect">
+            <a:avLst/>
+          </a:prstGeom>
+          <a:noFill/>
+          <a:ln w="28575">
+            <a:solidFill>
+              <a:srgbClr val="0432FF"/>
+            </a:solidFill>
+          </a:ln>
+        </p:spPr>
+        <p:txBody>
+          <a:bodyPr wrap="square">
+            <a:spAutoFit/>
+          </a:bodyPr>
+          <a:lstStyle/>
+          <a:p>
+            <a:r>
+              <a:rPr lang="en-GB" sz="2000" dirty="0">
+                <a:latin typeface="Arial" panose="020B0604020202020204" pitchFamily="34" charset="0"/>
+                <a:cs typeface="Arial" panose="020B0604020202020204" pitchFamily="34" charset="0"/>
+              </a:rPr>
+              <a:t>When AI is used in a PR, professional practice requires verification, refinement, and traceability.</a:t>
+            </a:r>
+          </a:p>
+        </p:txBody>
+      </p:sp>
+      <p:sp>
+        <p:nvSpPr>
+          <p:cNvPr id="62" name="TextBox 61">
+            <a:extLst>
+              <a:ext uri="{FF2B5EF4-FFF2-40B4-BE49-F238E27FC236}">
+                <a16:creationId xmlns:a16="http://schemas.microsoft.com/office/drawing/2014/main" id="{92379513-0362-52E9-A210-EC323A5333BE}"/>
+              </a:ext>
+            </a:extLst>
+          </p:cNvPr>
+          <p:cNvSpPr txBox="1"/>
+          <p:nvPr/>
+        </p:nvSpPr>
+        <p:spPr>
+          <a:xfrm>
+            <a:off x="6671160" y="943361"/>
+            <a:ext cx="1563033" cy="338554"/>
           </a:xfrm>
           <a:prstGeom prst="rect">
             <a:avLst/>
@@ -25060,8 +24992,8 @@
           <a:lstStyle/>
           <a:p>
             <a:r>
-              <a:rPr lang="en-US" dirty="0"/>
-              <a:t>maintainer</a:t>
+              <a:rPr lang="en-US" sz="1600" dirty="0"/>
+              <a:t>PR author</a:t>
             </a:r>
           </a:p>
         </p:txBody>
@@ -25158,33 +25090,15 @@
                                   </p:childTnLst>
                                 </p:cTn>
                               </p:par>
-                            </p:childTnLst>
-                          </p:cTn>
-                        </p:par>
-                      </p:childTnLst>
-                    </p:cTn>
-                  </p:par>
-                  <p:par>
-                    <p:cTn id="9" fill="hold">
-                      <p:stCondLst>
-                        <p:cond delay="indefinite"/>
-                      </p:stCondLst>
-                      <p:childTnLst>
-                        <p:par>
-                          <p:cTn id="10" fill="hold">
-                            <p:stCondLst>
-                              <p:cond delay="0"/>
-                            </p:stCondLst>
-                            <p:childTnLst>
                               <p:par>
-                                <p:cTn id="11" presetID="1" presetClass="entr" presetSubtype="0" fill="hold" nodeType="clickEffect">
+                                <p:cTn id="9" presetID="1" presetClass="entr" presetSubtype="0" fill="hold" nodeType="withEffect">
                                   <p:stCondLst>
                                     <p:cond delay="0"/>
                                   </p:stCondLst>
                                   <p:childTnLst>
                                     <p:set>
                                       <p:cBhvr>
-                                        <p:cTn id="12" dur="1" fill="hold">
+                                        <p:cTn id="10" dur="1" fill="hold">
                                           <p:stCondLst>
                                             <p:cond delay="0"/>
                                           </p:stCondLst>
@@ -25208,14 +25122,14 @@
                                 </p:cTn>
                               </p:par>
                               <p:par>
-                                <p:cTn id="13" presetID="1" presetClass="entr" presetSubtype="0" fill="hold" nodeType="withEffect">
+                                <p:cTn id="11" presetID="1" presetClass="entr" presetSubtype="0" fill="hold" nodeType="withEffect">
                                   <p:stCondLst>
                                     <p:cond delay="0"/>
                                   </p:stCondLst>
                                   <p:childTnLst>
                                     <p:set>
                                       <p:cBhvr>
-                                        <p:cTn id="14" dur="1" fill="hold">
+                                        <p:cTn id="12" dur="1" fill="hold">
                                           <p:stCondLst>
                                             <p:cond delay="0"/>
                                           </p:stCondLst>
@@ -25245,26 +25159,26 @@
                     </p:cTn>
                   </p:par>
                   <p:par>
-                    <p:cTn id="15" fill="hold">
+                    <p:cTn id="13" fill="hold">
                       <p:stCondLst>
                         <p:cond delay="indefinite"/>
                       </p:stCondLst>
                       <p:childTnLst>
                         <p:par>
-                          <p:cTn id="16" fill="hold">
+                          <p:cTn id="14" fill="hold">
                             <p:stCondLst>
                               <p:cond delay="0"/>
                             </p:stCondLst>
                             <p:childTnLst>
                               <p:par>
-                                <p:cTn id="17" presetID="1" presetClass="entr" presetSubtype="0" fill="hold" nodeType="clickEffect">
+                                <p:cTn id="15" presetID="1" presetClass="entr" presetSubtype="0" fill="hold" nodeType="clickEffect">
                                   <p:stCondLst>
                                     <p:cond delay="0"/>
                                   </p:stCondLst>
                                   <p:childTnLst>
                                     <p:set>
                                       <p:cBhvr>
-                                        <p:cTn id="18" dur="1" fill="hold">
+                                        <p:cTn id="16" dur="1" fill="hold">
                                           <p:stCondLst>
                                             <p:cond delay="0"/>
                                           </p:stCondLst>
@@ -25288,14 +25202,14 @@
                                 </p:cTn>
                               </p:par>
                               <p:par>
-                                <p:cTn id="19" presetID="1" presetClass="entr" presetSubtype="0" fill="hold" nodeType="withEffect">
+                                <p:cTn id="17" presetID="1" presetClass="entr" presetSubtype="0" fill="hold" nodeType="withEffect">
                                   <p:stCondLst>
                                     <p:cond delay="0"/>
                                   </p:stCondLst>
                                   <p:childTnLst>
                                     <p:set>
                                       <p:cBhvr>
-                                        <p:cTn id="20" dur="1" fill="hold">
+                                        <p:cTn id="18" dur="1" fill="hold">
                                           <p:stCondLst>
                                             <p:cond delay="0"/>
                                           </p:stCondLst>
@@ -25325,19 +25239,50 @@
                     </p:cTn>
                   </p:par>
                   <p:par>
-                    <p:cTn id="21" fill="hold">
+                    <p:cTn id="19" fill="hold">
                       <p:stCondLst>
                         <p:cond delay="indefinite"/>
                       </p:stCondLst>
                       <p:childTnLst>
                         <p:par>
-                          <p:cTn id="22" fill="hold">
+                          <p:cTn id="20" fill="hold">
                             <p:stCondLst>
                               <p:cond delay="0"/>
                             </p:stCondLst>
                             <p:childTnLst>
                               <p:par>
-                                <p:cTn id="23" presetID="1" presetClass="entr" presetSubtype="0" fill="hold" nodeType="clickEffect">
+                                <p:cTn id="21" presetID="1" presetClass="entr" presetSubtype="0" fill="hold" nodeType="clickEffect">
+                                  <p:stCondLst>
+                                    <p:cond delay="0"/>
+                                  </p:stCondLst>
+                                  <p:childTnLst>
+                                    <p:set>
+                                      <p:cBhvr>
+                                        <p:cTn id="22" dur="1" fill="hold">
+                                          <p:stCondLst>
+                                            <p:cond delay="0"/>
+                                          </p:stCondLst>
+                                        </p:cTn>
+                                        <p:tgtEl>
+                                          <p:spTgt spid="9">
+                                            <p:txEl>
+                                              <p:pRg st="6" end="6"/>
+                                            </p:txEl>
+                                          </p:spTgt>
+                                        </p:tgtEl>
+                                        <p:attrNameLst>
+                                          <p:attrName>style.visibility</p:attrName>
+                                        </p:attrNameLst>
+                                      </p:cBhvr>
+                                      <p:to>
+                                        <p:strVal val="visible"/>
+                                      </p:to>
+                                    </p:set>
+                                  </p:childTnLst>
+                                </p:cTn>
+                              </p:par>
+                              <p:par>
+                                <p:cTn id="23" presetID="1" presetClass="entr" presetSubtype="0" fill="hold" nodeType="withEffect">
                                   <p:stCondLst>
                                     <p:cond delay="0"/>
                                   </p:stCondLst>
@@ -25352,7 +25297,7 @@
                                         <p:tgtEl>
                                           <p:spTgt spid="9">
                                             <p:txEl>
-                                              <p:pRg st="6" end="6"/>
+                                              <p:pRg st="7" end="7"/>
                                             </p:txEl>
                                           </p:spTgt>
                                         </p:tgtEl>
@@ -25383,7 +25328,7 @@
                                         <p:tgtEl>
                                           <p:spTgt spid="9">
                                             <p:txEl>
-                                              <p:pRg st="7" end="7"/>
+                                              <p:pRg st="8" end="8"/>
                                             </p:txEl>
                                           </p:spTgt>
                                         </p:tgtEl>
@@ -25414,37 +25359,6 @@
                                         <p:tgtEl>
                                           <p:spTgt spid="9">
                                             <p:txEl>
-                                              <p:pRg st="8" end="8"/>
-                                            </p:txEl>
-                                          </p:spTgt>
-                                        </p:tgtEl>
-                                        <p:attrNameLst>
-                                          <p:attrName>style.visibility</p:attrName>
-                                        </p:attrNameLst>
-                                      </p:cBhvr>
-                                      <p:to>
-                                        <p:strVal val="visible"/>
-                                      </p:to>
-                                    </p:set>
-                                  </p:childTnLst>
-                                </p:cTn>
-                              </p:par>
-                              <p:par>
-                                <p:cTn id="29" presetID="1" presetClass="entr" presetSubtype="0" fill="hold" nodeType="withEffect">
-                                  <p:stCondLst>
-                                    <p:cond delay="0"/>
-                                  </p:stCondLst>
-                                  <p:childTnLst>
-                                    <p:set>
-                                      <p:cBhvr>
-                                        <p:cTn id="30" dur="1" fill="hold">
-                                          <p:stCondLst>
-                                            <p:cond delay="0"/>
-                                          </p:stCondLst>
-                                        </p:cTn>
-                                        <p:tgtEl>
-                                          <p:spTgt spid="9">
-                                            <p:txEl>
                                               <p:pRg st="9" end="9"/>
                                             </p:txEl>
                                           </p:spTgt>
@@ -25460,8 +25374,26 @@
                                   </p:childTnLst>
                                 </p:cTn>
                               </p:par>
+                            </p:childTnLst>
+                          </p:cTn>
+                        </p:par>
+                      </p:childTnLst>
+                    </p:cTn>
+                  </p:par>
+                  <p:par>
+                    <p:cTn id="29" fill="hold">
+                      <p:stCondLst>
+                        <p:cond delay="indefinite"/>
+                      </p:stCondLst>
+                      <p:childTnLst>
+                        <p:par>
+                          <p:cTn id="30" fill="hold">
+                            <p:stCondLst>
+                              <p:cond delay="0"/>
+                            </p:stCondLst>
+                            <p:childTnLst>
                               <p:par>
-                                <p:cTn id="31" presetID="1" presetClass="entr" presetSubtype="0" fill="hold" nodeType="withEffect">
+                                <p:cTn id="31" presetID="1" presetClass="entr" presetSubtype="0" fill="hold" grpId="0" nodeType="clickEffect">
                                   <p:stCondLst>
                                     <p:cond delay="0"/>
                                   </p:stCondLst>
@@ -25474,11 +25406,34 @@
                                           </p:stCondLst>
                                         </p:cTn>
                                         <p:tgtEl>
-                                          <p:spTgt spid="9">
-                                            <p:txEl>
-                                              <p:pRg st="10" end="10"/>
-                                            </p:txEl>
-                                          </p:spTgt>
+                                          <p:spTgt spid="61"/>
+                                        </p:tgtEl>
+                                        <p:attrNameLst>
+                                          <p:attrName>style.visibility</p:attrName>
+                                        </p:attrNameLst>
+                                      </p:cBhvr>
+                                      <p:to>
+                                        <p:strVal val="visible"/>
+                                      </p:to>
+                                    </p:set>
+                                  </p:childTnLst>
+                                </p:cTn>
+                              </p:par>
+                              <p:par>
+                                <p:cTn id="33" presetID="1" presetClass="entr" presetSubtype="0" fill="hold" grpId="0" nodeType="withEffect">
+                                  <p:stCondLst>
+                                    <p:cond delay="0"/>
+                                  </p:stCondLst>
+                                  <p:childTnLst>
+                                    <p:set>
+                                      <p:cBhvr>
+                                        <p:cTn id="34" dur="1" fill="hold">
+                                          <p:stCondLst>
+                                            <p:cond delay="0"/>
+                                          </p:stCondLst>
+                                        </p:cTn>
+                                        <p:tgtEl>
+                                          <p:spTgt spid="62"/>
                                         </p:tgtEl>
                                         <p:attrNameLst>
                                           <p:attrName>style.visibility</p:attrName>
@@ -25518,6 +25473,10 @@
         </p:cTn>
       </p:par>
     </p:tnLst>
+    <p:bldLst>
+      <p:bldP spid="61" grpId="0"/>
+      <p:bldP spid="62" grpId="0"/>
+    </p:bldLst>
   </p:timing>
 </p:sld>
 </file>
@@ -25826,6 +25785,84 @@
   <p:clrMapOvr>
     <a:masterClrMapping/>
   </p:clrMapOvr>
+  <p:timing>
+    <p:tnLst>
+      <p:par>
+        <p:cTn id="1" dur="indefinite" restart="never" nodeType="tmRoot">
+          <p:childTnLst>
+            <p:seq concurrent="1" nextAc="seek">
+              <p:cTn id="2" dur="indefinite" nodeType="mainSeq">
+                <p:childTnLst>
+                  <p:par>
+                    <p:cTn id="3" fill="hold">
+                      <p:stCondLst>
+                        <p:cond delay="indefinite"/>
+                      </p:stCondLst>
+                      <p:childTnLst>
+                        <p:par>
+                          <p:cTn id="4" fill="hold">
+                            <p:stCondLst>
+                              <p:cond delay="0"/>
+                            </p:stCondLst>
+                            <p:childTnLst>
+                              <p:par>
+                                <p:cTn id="5" presetID="1" presetClass="entr" presetSubtype="0" fill="hold" grpId="0" nodeType="clickEffect">
+                                  <p:stCondLst>
+                                    <p:cond delay="0"/>
+                                  </p:stCondLst>
+                                  <p:childTnLst>
+                                    <p:set>
+                                      <p:cBhvr>
+                                        <p:cTn id="6" dur="1" fill="hold">
+                                          <p:stCondLst>
+                                            <p:cond delay="0"/>
+                                          </p:stCondLst>
+                                        </p:cTn>
+                                        <p:tgtEl>
+                                          <p:spTgt spid="30"/>
+                                        </p:tgtEl>
+                                        <p:attrNameLst>
+                                          <p:attrName>style.visibility</p:attrName>
+                                        </p:attrNameLst>
+                                      </p:cBhvr>
+                                      <p:to>
+                                        <p:strVal val="visible"/>
+                                      </p:to>
+                                    </p:set>
+                                  </p:childTnLst>
+                                </p:cTn>
+                              </p:par>
+                            </p:childTnLst>
+                          </p:cTn>
+                        </p:par>
+                      </p:childTnLst>
+                    </p:cTn>
+                  </p:par>
+                </p:childTnLst>
+              </p:cTn>
+              <p:prevCondLst>
+                <p:cond evt="onPrev" delay="0">
+                  <p:tgtEl>
+                    <p:sldTgt/>
+                  </p:tgtEl>
+                </p:cond>
+              </p:prevCondLst>
+              <p:nextCondLst>
+                <p:cond evt="onNext" delay="0">
+                  <p:tgtEl>
+                    <p:sldTgt/>
+                  </p:tgtEl>
+                </p:cond>
+              </p:nextCondLst>
+            </p:seq>
+          </p:childTnLst>
+        </p:cTn>
+      </p:par>
+    </p:tnLst>
+    <p:bldLst>
+      <p:bldP spid="30" grpId="0" animBg="1"/>
+    </p:bldLst>
+  </p:timing>
 </p:sld>
 </file>
 
@@ -25929,7 +25966,7 @@
         <p:spPr>
           <a:xfrm>
             <a:off x="614266" y="2274838"/>
-            <a:ext cx="5799176" cy="3970318"/>
+            <a:ext cx="5799176" cy="3477875"/>
           </a:xfrm>
           <a:prstGeom prst="rect">
             <a:avLst/>
@@ -25958,7 +25995,7 @@
               <a:buNone/>
             </a:pPr>
             <a:r>
-              <a:rPr lang="en-GB" sz="2200" dirty="0">
+              <a:rPr lang="en-GB" sz="2000" dirty="0">
                 <a:latin typeface="Arial" panose="020B0604020202020204" pitchFamily="34" charset="0"/>
                 <a:cs typeface="Arial" panose="020B0604020202020204" pitchFamily="34" charset="0"/>
               </a:rPr>
@@ -25982,7 +26019,7 @@
               <a:buNone/>
             </a:pPr>
             <a:r>
-              <a:rPr lang="en-GB" sz="2400" dirty="0">
+              <a:rPr lang="en-GB" sz="2000" dirty="0">
                 <a:latin typeface="Arial" panose="020B0604020202020204" pitchFamily="34" charset="0"/>
                 <a:cs typeface="Arial" panose="020B0604020202020204" pitchFamily="34" charset="0"/>
               </a:rPr>
@@ -26006,7 +26043,7 @@
               <a:buNone/>
             </a:pPr>
             <a:r>
-              <a:rPr lang="en-GB" sz="2400" dirty="0">
+              <a:rPr lang="en-GB" sz="2000" dirty="0">
                 <a:latin typeface="Arial" panose="020B0604020202020204" pitchFamily="34" charset="0"/>
                 <a:cs typeface="Arial" panose="020B0604020202020204" pitchFamily="34" charset="0"/>
               </a:rPr>
@@ -26030,10 +26067,10 @@
               <a:buNone/>
             </a:pPr>
             <a:r>
-              <a:rPr lang="en-GB" sz="2400" dirty="0"/>
-              <a:t>he PR itself was closed without merge</a:t>
-            </a:r>
-            <a:endParaRPr lang="en-GB" sz="2200" dirty="0">
+              <a:rPr lang="en-GB" sz="2000" dirty="0"/>
+              <a:t>The PR itself was closed without merge</a:t>
+            </a:r>
+            <a:endParaRPr lang="en-GB" sz="2000" dirty="0">
               <a:latin typeface="Arial" panose="020B0604020202020204" pitchFamily="34" charset="0"/>
               <a:cs typeface="Arial" panose="020B0604020202020204" pitchFamily="34" charset="0"/>
             </a:endParaRPr>
@@ -26172,6 +26209,276 @@
   <p:clrMapOvr>
     <a:masterClrMapping/>
   </p:clrMapOvr>
+  <p:timing>
+    <p:tnLst>
+      <p:par>
+        <p:cTn id="1" dur="indefinite" restart="never" nodeType="tmRoot">
+          <p:childTnLst>
+            <p:seq concurrent="1" nextAc="seek">
+              <p:cTn id="2" dur="indefinite" nodeType="mainSeq">
+                <p:childTnLst>
+                  <p:par>
+                    <p:cTn id="3" fill="hold">
+                      <p:stCondLst>
+                        <p:cond delay="indefinite"/>
+                      </p:stCondLst>
+                      <p:childTnLst>
+                        <p:par>
+                          <p:cTn id="4" fill="hold">
+                            <p:stCondLst>
+                              <p:cond delay="0"/>
+                            </p:stCondLst>
+                            <p:childTnLst>
+                              <p:par>
+                                <p:cTn id="5" presetID="1" presetClass="entr" presetSubtype="0" fill="hold" nodeType="clickEffect">
+                                  <p:stCondLst>
+                                    <p:cond delay="0"/>
+                                  </p:stCondLst>
+                                  <p:childTnLst>
+                                    <p:set>
+                                      <p:cBhvr>
+                                        <p:cTn id="6" dur="1" fill="hold">
+                                          <p:stCondLst>
+                                            <p:cond delay="0"/>
+                                          </p:stCondLst>
+                                        </p:cTn>
+                                        <p:tgtEl>
+                                          <p:spTgt spid="3">
+                                            <p:txEl>
+                                              <p:pRg st="0" end="0"/>
+                                            </p:txEl>
+                                          </p:spTgt>
+                                        </p:tgtEl>
+                                        <p:attrNameLst>
+                                          <p:attrName>style.visibility</p:attrName>
+                                        </p:attrNameLst>
+                                      </p:cBhvr>
+                                      <p:to>
+                                        <p:strVal val="visible"/>
+                                      </p:to>
+                                    </p:set>
+                                  </p:childTnLst>
+                                </p:cTn>
+                              </p:par>
+                              <p:par>
+                                <p:cTn id="7" presetID="1" presetClass="entr" presetSubtype="0" fill="hold" nodeType="withEffect">
+                                  <p:stCondLst>
+                                    <p:cond delay="0"/>
+                                  </p:stCondLst>
+                                  <p:childTnLst>
+                                    <p:set>
+                                      <p:cBhvr>
+                                        <p:cTn id="8" dur="1" fill="hold">
+                                          <p:stCondLst>
+                                            <p:cond delay="0"/>
+                                          </p:stCondLst>
+                                        </p:cTn>
+                                        <p:tgtEl>
+                                          <p:spTgt spid="3">
+                                            <p:txEl>
+                                              <p:pRg st="1" end="1"/>
+                                            </p:txEl>
+                                          </p:spTgt>
+                                        </p:tgtEl>
+                                        <p:attrNameLst>
+                                          <p:attrName>style.visibility</p:attrName>
+                                        </p:attrNameLst>
+                                      </p:cBhvr>
+                                      <p:to>
+                                        <p:strVal val="visible"/>
+                                      </p:to>
+                                    </p:set>
+                                  </p:childTnLst>
+                                </p:cTn>
+                              </p:par>
+                            </p:childTnLst>
+                          </p:cTn>
+                        </p:par>
+                      </p:childTnLst>
+                    </p:cTn>
+                  </p:par>
+                  <p:par>
+                    <p:cTn id="9" fill="hold">
+                      <p:stCondLst>
+                        <p:cond delay="indefinite"/>
+                      </p:stCondLst>
+                      <p:childTnLst>
+                        <p:par>
+                          <p:cTn id="10" fill="hold">
+                            <p:stCondLst>
+                              <p:cond delay="0"/>
+                            </p:stCondLst>
+                            <p:childTnLst>
+                              <p:par>
+                                <p:cTn id="11" presetID="1" presetClass="entr" presetSubtype="0" fill="hold" nodeType="clickEffect">
+                                  <p:stCondLst>
+                                    <p:cond delay="0"/>
+                                  </p:stCondLst>
+                                  <p:childTnLst>
+                                    <p:set>
+                                      <p:cBhvr>
+                                        <p:cTn id="12" dur="1" fill="hold">
+                                          <p:stCondLst>
+                                            <p:cond delay="0"/>
+                                          </p:stCondLst>
+                                        </p:cTn>
+                                        <p:tgtEl>
+                                          <p:spTgt spid="3">
+                                            <p:txEl>
+                                              <p:pRg st="2" end="2"/>
+                                            </p:txEl>
+                                          </p:spTgt>
+                                        </p:tgtEl>
+                                        <p:attrNameLst>
+                                          <p:attrName>style.visibility</p:attrName>
+                                        </p:attrNameLst>
+                                      </p:cBhvr>
+                                      <p:to>
+                                        <p:strVal val="visible"/>
+                                      </p:to>
+                                    </p:set>
+                                  </p:childTnLst>
+                                </p:cTn>
+                              </p:par>
+                              <p:par>
+                                <p:cTn id="13" presetID="1" presetClass="entr" presetSubtype="0" fill="hold" nodeType="withEffect">
+                                  <p:stCondLst>
+                                    <p:cond delay="0"/>
+                                  </p:stCondLst>
+                                  <p:childTnLst>
+                                    <p:set>
+                                      <p:cBhvr>
+                                        <p:cTn id="14" dur="1" fill="hold">
+                                          <p:stCondLst>
+                                            <p:cond delay="0"/>
+                                          </p:stCondLst>
+                                        </p:cTn>
+                                        <p:tgtEl>
+                                          <p:spTgt spid="3">
+                                            <p:txEl>
+                                              <p:pRg st="3" end="3"/>
+                                            </p:txEl>
+                                          </p:spTgt>
+                                        </p:tgtEl>
+                                        <p:attrNameLst>
+                                          <p:attrName>style.visibility</p:attrName>
+                                        </p:attrNameLst>
+                                      </p:cBhvr>
+                                      <p:to>
+                                        <p:strVal val="visible"/>
+                                      </p:to>
+                                    </p:set>
+                                  </p:childTnLst>
+                                </p:cTn>
+                              </p:par>
+                            </p:childTnLst>
+                          </p:cTn>
+                        </p:par>
+                      </p:childTnLst>
+                    </p:cTn>
+                  </p:par>
+                  <p:par>
+                    <p:cTn id="15" fill="hold">
+                      <p:stCondLst>
+                        <p:cond delay="indefinite"/>
+                      </p:stCondLst>
+                      <p:childTnLst>
+                        <p:par>
+                          <p:cTn id="16" fill="hold">
+                            <p:stCondLst>
+                              <p:cond delay="0"/>
+                            </p:stCondLst>
+                            <p:childTnLst>
+                              <p:par>
+                                <p:cTn id="17" presetID="1" presetClass="entr" presetSubtype="0" fill="hold" nodeType="clickEffect">
+                                  <p:stCondLst>
+                                    <p:cond delay="0"/>
+                                  </p:stCondLst>
+                                  <p:childTnLst>
+                                    <p:set>
+                                      <p:cBhvr>
+                                        <p:cTn id="18" dur="1" fill="hold">
+                                          <p:stCondLst>
+                                            <p:cond delay="0"/>
+                                          </p:stCondLst>
+                                        </p:cTn>
+                                        <p:tgtEl>
+                                          <p:spTgt spid="3">
+                                            <p:txEl>
+                                              <p:pRg st="4" end="4"/>
+                                            </p:txEl>
+                                          </p:spTgt>
+                                        </p:tgtEl>
+                                        <p:attrNameLst>
+                                          <p:attrName>style.visibility</p:attrName>
+                                        </p:attrNameLst>
+                                      </p:cBhvr>
+                                      <p:to>
+                                        <p:strVal val="visible"/>
+                                      </p:to>
+                                    </p:set>
+                                  </p:childTnLst>
+                                </p:cTn>
+                              </p:par>
+                              <p:par>
+                                <p:cTn id="19" presetID="1" presetClass="entr" presetSubtype="0" fill="hold" nodeType="withEffect">
+                                  <p:stCondLst>
+                                    <p:cond delay="0"/>
+                                  </p:stCondLst>
+                                  <p:childTnLst>
+                                    <p:set>
+                                      <p:cBhvr>
+                                        <p:cTn id="20" dur="1" fill="hold">
+                                          <p:stCondLst>
+                                            <p:cond delay="0"/>
+                                          </p:stCondLst>
+                                        </p:cTn>
+                                        <p:tgtEl>
+                                          <p:spTgt spid="3">
+                                            <p:txEl>
+                                              <p:pRg st="5" end="5"/>
+                                            </p:txEl>
+                                          </p:spTgt>
+                                        </p:tgtEl>
+                                        <p:attrNameLst>
+                                          <p:attrName>style.visibility</p:attrName>
+                                        </p:attrNameLst>
+                                      </p:cBhvr>
+                                      <p:to>
+                                        <p:strVal val="visible"/>
+                                      </p:to>
+                                    </p:set>
+                                  </p:childTnLst>
+                                </p:cTn>
+                              </p:par>
+                            </p:childTnLst>
+                          </p:cTn>
+                        </p:par>
+                      </p:childTnLst>
+                    </p:cTn>
+                  </p:par>
+                </p:childTnLst>
+              </p:cTn>
+              <p:prevCondLst>
+                <p:cond evt="onPrev" delay="0">
+                  <p:tgtEl>
+                    <p:sldTgt/>
+                  </p:tgtEl>
+                </p:cond>
+              </p:prevCondLst>
+              <p:nextCondLst>
+                <p:cond evt="onNext" delay="0">
+                  <p:tgtEl>
+                    <p:sldTgt/>
+                  </p:tgtEl>
+                </p:cond>
+              </p:nextCondLst>
+            </p:seq>
+          </p:childTnLst>
+        </p:cTn>
+      </p:par>
+    </p:tnLst>
+  </p:timing>
 </p:sld>
 </file>
 
@@ -27319,10 +27626,10 @@
           </p:nvGrpSpPr>
           <p:grpSpPr>
             <a:xfrm>
-              <a:off x="5958873" y="5299466"/>
-              <a:ext cx="2639432" cy="1032949"/>
-              <a:chOff x="8658529" y="5684475"/>
-              <a:chExt cx="2639432" cy="1032949"/>
+              <a:off x="6314473" y="5299466"/>
+              <a:ext cx="2520899" cy="1032949"/>
+              <a:chOff x="9014129" y="5684475"/>
+              <a:chExt cx="2520899" cy="1032949"/>
             </a:xfrm>
           </p:grpSpPr>
           <p:pic>
@@ -27399,7 +27706,7 @@
             </p:nvSpPr>
             <p:spPr>
               <a:xfrm>
-                <a:off x="10240348" y="6412382"/>
+                <a:off x="10477415" y="6412382"/>
                 <a:ext cx="1057613" cy="276999"/>
               </a:xfrm>
               <a:prstGeom prst="rect">
@@ -27434,7 +27741,7 @@
             </p:nvSpPr>
             <p:spPr>
               <a:xfrm>
-                <a:off x="8658529" y="6440425"/>
+                <a:off x="9014129" y="6440425"/>
                 <a:ext cx="1333609" cy="276999"/>
               </a:xfrm>
               <a:prstGeom prst="rect">
@@ -28800,6 +29107,129 @@
   <p:clrMapOvr>
     <a:masterClrMapping/>
   </p:clrMapOvr>
+  <p:timing>
+    <p:tnLst>
+      <p:par>
+        <p:cTn id="1" dur="indefinite" restart="never" nodeType="tmRoot">
+          <p:childTnLst>
+            <p:seq concurrent="1" nextAc="seek">
+              <p:cTn id="2" dur="indefinite" nodeType="mainSeq">
+                <p:childTnLst>
+                  <p:par>
+                    <p:cTn id="3" fill="hold">
+                      <p:stCondLst>
+                        <p:cond delay="indefinite"/>
+                      </p:stCondLst>
+                      <p:childTnLst>
+                        <p:par>
+                          <p:cTn id="4" fill="hold">
+                            <p:stCondLst>
+                              <p:cond delay="0"/>
+                            </p:stCondLst>
+                            <p:childTnLst>
+                              <p:par>
+                                <p:cTn id="5" presetID="1" presetClass="entr" presetSubtype="0" fill="hold" nodeType="clickEffect">
+                                  <p:stCondLst>
+                                    <p:cond delay="0"/>
+                                  </p:stCondLst>
+                                  <p:childTnLst>
+                                    <p:set>
+                                      <p:cBhvr>
+                                        <p:cTn id="6" dur="1" fill="hold">
+                                          <p:stCondLst>
+                                            <p:cond delay="0"/>
+                                          </p:stCondLst>
+                                        </p:cTn>
+                                        <p:tgtEl>
+                                          <p:spTgt spid="5"/>
+                                        </p:tgtEl>
+                                        <p:attrNameLst>
+                                          <p:attrName>style.visibility</p:attrName>
+                                        </p:attrNameLst>
+                                      </p:cBhvr>
+                                      <p:to>
+                                        <p:strVal val="visible"/>
+                                      </p:to>
+                                    </p:set>
+                                  </p:childTnLst>
+                                </p:cTn>
+                              </p:par>
+                            </p:childTnLst>
+                          </p:cTn>
+                        </p:par>
+                      </p:childTnLst>
+                    </p:cTn>
+                  </p:par>
+                  <p:par>
+                    <p:cTn id="7" fill="hold">
+                      <p:stCondLst>
+                        <p:cond delay="indefinite"/>
+                      </p:stCondLst>
+                      <p:childTnLst>
+                        <p:par>
+                          <p:cTn id="8" fill="hold">
+                            <p:stCondLst>
+                              <p:cond delay="0"/>
+                            </p:stCondLst>
+                            <p:childTnLst>
+                              <p:par>
+                                <p:cTn id="9" presetID="1" presetClass="entr" presetSubtype="0" fill="hold" grpId="0" nodeType="clickEffect">
+                                  <p:stCondLst>
+                                    <p:cond delay="0"/>
+                                  </p:stCondLst>
+                                  <p:childTnLst>
+                                    <p:set>
+                                      <p:cBhvr>
+                                        <p:cTn id="10" dur="1" fill="hold">
+                                          <p:stCondLst>
+                                            <p:cond delay="0"/>
+                                          </p:stCondLst>
+                                        </p:cTn>
+                                        <p:tgtEl>
+                                          <p:spTgt spid="4"/>
+                                        </p:tgtEl>
+                                        <p:attrNameLst>
+                                          <p:attrName>style.visibility</p:attrName>
+                                        </p:attrNameLst>
+                                      </p:cBhvr>
+                                      <p:to>
+                                        <p:strVal val="visible"/>
+                                      </p:to>
+                                    </p:set>
+                                  </p:childTnLst>
+                                </p:cTn>
+                              </p:par>
+                            </p:childTnLst>
+                          </p:cTn>
+                        </p:par>
+                      </p:childTnLst>
+                    </p:cTn>
+                  </p:par>
+                </p:childTnLst>
+              </p:cTn>
+              <p:prevCondLst>
+                <p:cond evt="onPrev" delay="0">
+                  <p:tgtEl>
+                    <p:sldTgt/>
+                  </p:tgtEl>
+                </p:cond>
+              </p:prevCondLst>
+              <p:nextCondLst>
+                <p:cond evt="onNext" delay="0">
+                  <p:tgtEl>
+                    <p:sldTgt/>
+                  </p:tgtEl>
+                </p:cond>
+              </p:nextCondLst>
+            </p:seq>
+          </p:childTnLst>
+        </p:cTn>
+      </p:par>
+    </p:tnLst>
+    <p:bldLst>
+      <p:bldP spid="4" grpId="0" animBg="1"/>
+    </p:bldLst>
+  </p:timing>
 </p:sld>
 </file>
 

</xml_diff>